<commit_message>
Refine professor-facing research pages and presentation
Lead with an inspectable ranking error, clarify exploratory evidence and the proposed annotation pilot, and unify reader navigation. Add a one-page research PDF, refresh the editable deck and previews, and validate rendered-report links while preserving historical evidence.
</commit_message>
<xml_diff>
--- a/docs/assets/bizhallu_interview_v2.pptx
+++ b/docs/assets/bizhallu_interview_v2.pptx
@@ -2,22 +2,22 @@
 <file path=ppt/presentation.xml><?xml version="1.0" encoding="utf-8"?>
 <p:presentation xmlns:p="http://schemas.openxmlformats.org/presentationml/2006/main">
   <p:sldMasterIdLst>
-    <p:sldMasterId xmlns:r="http://schemas.openxmlformats.org/officeDocument/2006/relationships" id="2147483648" r:id="R7ee7a3f10a8b4d06"/>
+    <p:sldMasterId xmlns:r="http://schemas.openxmlformats.org/officeDocument/2006/relationships" id="2147483648" r:id="R5fad81ba96214384"/>
   </p:sldMasterIdLst>
   <p:notesMasterIdLst>
-    <p:notesMasterId xmlns:r="http://schemas.openxmlformats.org/officeDocument/2006/relationships" r:id="R1a82c0bf82d84ea2"/>
+    <p:notesMasterId xmlns:r="http://schemas.openxmlformats.org/officeDocument/2006/relationships" r:id="R6ce0562ca9324c9e"/>
   </p:notesMasterIdLst>
   <p:sldIdLst>
-    <p:sldId xmlns:r="http://schemas.openxmlformats.org/officeDocument/2006/relationships" id="256" r:id="R8b75c3ef38a240a4"/>
-    <p:sldId xmlns:r="http://schemas.openxmlformats.org/officeDocument/2006/relationships" id="257" r:id="R6f3c7b40ab824ea1"/>
-    <p:sldId xmlns:r="http://schemas.openxmlformats.org/officeDocument/2006/relationships" id="258" r:id="R84a6e14a05e842b8"/>
-    <p:sldId xmlns:r="http://schemas.openxmlformats.org/officeDocument/2006/relationships" id="259" r:id="Rbbc5cab810804e3a"/>
-    <p:sldId xmlns:r="http://schemas.openxmlformats.org/officeDocument/2006/relationships" id="260" r:id="Rcedb28063bd74d25"/>
-    <p:sldId xmlns:r="http://schemas.openxmlformats.org/officeDocument/2006/relationships" id="261" r:id="Rc1e513e74ae6406c"/>
-    <p:sldId xmlns:r="http://schemas.openxmlformats.org/officeDocument/2006/relationships" id="262" r:id="Rc51bbf7aed944012"/>
-    <p:sldId xmlns:r="http://schemas.openxmlformats.org/officeDocument/2006/relationships" id="263" r:id="Rf91cfdac3f9a4668"/>
-    <p:sldId xmlns:r="http://schemas.openxmlformats.org/officeDocument/2006/relationships" id="264" r:id="Rc996d8630af047ea"/>
-    <p:sldId xmlns:r="http://schemas.openxmlformats.org/officeDocument/2006/relationships" id="265" r:id="Rfffaf57d60f04c39"/>
+    <p:sldId xmlns:r="http://schemas.openxmlformats.org/officeDocument/2006/relationships" id="256" r:id="R2e68154f9d204ef9"/>
+    <p:sldId xmlns:r="http://schemas.openxmlformats.org/officeDocument/2006/relationships" id="257" r:id="Ra474c051823f4f99"/>
+    <p:sldId xmlns:r="http://schemas.openxmlformats.org/officeDocument/2006/relationships" id="258" r:id="R43de99c6fb7c4fcd"/>
+    <p:sldId xmlns:r="http://schemas.openxmlformats.org/officeDocument/2006/relationships" id="259" r:id="R91e120852f1e412a"/>
+    <p:sldId xmlns:r="http://schemas.openxmlformats.org/officeDocument/2006/relationships" id="260" r:id="Rdd86df233cf74537"/>
+    <p:sldId xmlns:r="http://schemas.openxmlformats.org/officeDocument/2006/relationships" id="261" r:id="Raf4deae29c7741f9"/>
+    <p:sldId xmlns:r="http://schemas.openxmlformats.org/officeDocument/2006/relationships" id="262" r:id="R3d5afad523984e4f"/>
+    <p:sldId xmlns:r="http://schemas.openxmlformats.org/officeDocument/2006/relationships" id="263" r:id="R4057e8737c0b4404"/>
+    <p:sldId xmlns:r="http://schemas.openxmlformats.org/officeDocument/2006/relationships" id="264" r:id="R7bfda2cb9d864c8f"/>
+    <p:sldId xmlns:r="http://schemas.openxmlformats.org/officeDocument/2006/relationships" id="265" r:id="R988a4e630d714065"/>
   </p:sldIdLst>
   <p:sldSz cx="12192000" cy="6858000"/>
   <p:notesSz cx="6858000" cy="9144000"/>
@@ -451,7 +451,7 @@
           <a:lstStyle xmlns:a="http://schemas.openxmlformats.org/drawingml/2006/main"/>
           <a:p xmlns:a="http://schemas.openxmlformats.org/drawingml/2006/main">
             <a:r>
-              <a:t>BizHallu studies a practical reporting problem: when an AI writes business analysis, can we trace its claims back to the evidence? I directed the project with AI-assisted implementation and review. My focus is on the accounting and operational decisions behind the numbers, alongside the model evaluation.</a:t>
+              <a:t>BizHallu asks whether AI-generated business conclusions follow from the transaction evidence. I directed the project with AI-assisted implementation and review. My accounting and supply-management background motivates the distinction between a number that reconciles and a relationship that supports a decision. I will begin with a concrete ranking error, then discuss the evaluation and a proposed comparison.</a:t>
             </a:r>
           </a:p>
           <a:p xmlns:a="http://schemas.openxmlformats.org/drawingml/2006/main">
@@ -471,17 +471,17 @@
           </a:p>
           <a:p xmlns:a="http://schemas.openxmlformats.org/drawingml/2006/main">
             <a:r>
+              <a:t>https://doi.org/10.24432/C5BW33</a:t>
+            </a:r>
+          </a:p>
+          <a:p xmlns:a="http://schemas.openxmlformats.org/drawingml/2006/main">
+            <a:r>
               <a:t>Statistical source SHA-256: 096bae57edec06e74c6f4e029419b844adb421d252a1f8c60335ae1859dc0727</a:t>
             </a:r>
           </a:p>
           <a:p xmlns:a="http://schemas.openxmlformats.org/drawingml/2006/main">
             <a:r>
               <a:t>B2 sensitivity source SHA-256: 6c79de033666a5f9af5bdcf18222a761b186bf6404ac566d7b7a1284b834494d</a:t>
-            </a:r>
-          </a:p>
-          <a:p xmlns:a="http://schemas.openxmlformats.org/drawingml/2006/main">
-            <a:r>
-              <a:t>Speaking time: 20 seconds planned, not measured.</a:t>
             </a:r>
           </a:p>
         </p:txBody>
@@ -551,7 +551,7 @@
           <a:lstStyle xmlns:a="http://schemas.openxmlformats.org/drawingml/2006/main"/>
           <a:p xmlns:a="http://schemas.openxmlformats.org/drawingml/2006/main">
             <a:r>
-              <a:t>For a professor, my concrete request is feedback on the unit of annotation and comparison design. I would begin with a top-three verifier that uses the question, answer, metric contract and evidence, without evaluation labels or gold answers as inputs. Semantic consistency, attention methods and a faithful adjacent-step energy implementation remain comparison options. The new confirmation study stays sealed until the prediction and evaluation process is ready.</a:t>
+              <a:t>My request is a focused discussion of the annotation unit and comparison design. The immediate deliverable would be a small independently reviewed relation set and one evidence checker. The existing 48-context design offers a later evaluation path, but it remains unexecuted and estimation-focused. Model and prompt settings, reviewers, and the prediction protocol must be ready first. A second dataset or model would follow only after this smaller comparison is credible.</a:t>
             </a:r>
           </a:p>
           <a:p xmlns:a="http://schemas.openxmlformats.org/drawingml/2006/main">
@@ -571,7 +571,7 @@
           </a:p>
           <a:p xmlns:a="http://schemas.openxmlformats.org/drawingml/2006/main">
             <a:r>
-              <a:t>https://github.com/Yuchi-Wang02/bizhallu/blob/main/reports/bizhallu_statistics_v2_report.json</a:t>
+              <a:t>https://github.com/Yuchi-Wang02/bizhallu/blob/main/configs/confirmation_set_v1_protocol.json</a:t>
             </a:r>
           </a:p>
           <a:p xmlns:a="http://schemas.openxmlformats.org/drawingml/2006/main">
@@ -582,11 +582,6 @@
           <a:p xmlns:a="http://schemas.openxmlformats.org/drawingml/2006/main">
             <a:r>
               <a:t>B2 sensitivity source SHA-256: 6c79de033666a5f9af5bdcf18222a761b186bf6404ac566d7b7a1284b834494d</a:t>
-            </a:r>
-          </a:p>
-          <a:p xmlns:a="http://schemas.openxmlformats.org/drawingml/2006/main">
-            <a:r>
-              <a:t>Speaking time: 25 seconds planned, not measured.</a:t>
             </a:r>
           </a:p>
         </p:txBody>
@@ -684,11 +679,6 @@
               <a:t>B2 sensitivity source SHA-256: 6c79de033666a5f9af5bdcf18222a761b186bf6404ac566d7b7a1284b834494d</a:t>
             </a:r>
           </a:p>
-          <a:p xmlns:a="http://schemas.openxmlformats.org/drawingml/2006/main">
-            <a:r>
-              <a:t>Speaking time: 35 seconds planned, not measured.</a:t>
-            </a:r>
-          </a:p>
         </p:txBody>
       </p:sp>
       <p:sp>
@@ -784,11 +774,6 @@
               <a:t>B2 sensitivity source SHA-256: 6c79de033666a5f9af5bdcf18222a761b186bf6404ac566d7b7a1284b834494d</a:t>
             </a:r>
           </a:p>
-          <a:p xmlns:a="http://schemas.openxmlformats.org/drawingml/2006/main">
-            <a:r>
-              <a:t>Speaking time: 30 seconds planned, not measured.</a:t>
-            </a:r>
-          </a:p>
         </p:txBody>
       </p:sp>
       <p:sp>
@@ -856,7 +841,7 @@
           <a:lstStyle xmlns:a="http://schemas.openxmlformats.org/drawingml/2006/main"/>
           <a:p xmlns:a="http://schemas.openxmlformats.org/drawingml/2006/main">
             <a:r>
-              <a:t>Metric definitions matter before we judge an answer. Negative transaction value is not the same as confirmed physical returns, because fee and adjustment records can contribute. Merchandise scope also depends on a documented stock-code rule. I preserve the historical calculation and provide a versioned definition amendment instead of silently rewriting old gold answers. Without cost, inventory or delivery data, I cannot claim profit analysis or inventory optimization.</a:t>
+              <a:t>The research question is what uncertainty signals miss when copied facts form an incorrect business relationship. A rank only makes sense with its product, metric and comparison scope. The proposed comparison asks whether an evidence checker adds useful information under matched conditions. Business definitions remain part of the task: negative transaction value can include fees and adjustments, so it cannot establish physical returns. The historical merchandise definition uses a documented stock-code heuristic.</a:t>
             </a:r>
           </a:p>
           <a:p xmlns:a="http://schemas.openxmlformats.org/drawingml/2006/main">
@@ -871,6 +856,11 @@
           </a:p>
           <a:p xmlns:a="http://schemas.openxmlformats.org/drawingml/2006/main">
             <a:r>
+              <a:t>https://github.com/Yuchi-Wang02/bizhallu/blob/main/configs/relation_annotation_v2.json</a:t>
+            </a:r>
+          </a:p>
+          <a:p xmlns:a="http://schemas.openxmlformats.org/drawingml/2006/main">
+            <a:r>
               <a:t>https://github.com/Yuchi-Wang02/bizhallu/blob/main/configs/business_metric_contract_v1_1.json</a:t>
             </a:r>
           </a:p>
@@ -882,11 +872,6 @@
           <a:p xmlns:a="http://schemas.openxmlformats.org/drawingml/2006/main">
             <a:r>
               <a:t>B2 sensitivity source SHA-256: 6c79de033666a5f9af5bdcf18222a761b186bf6404ac566d7b7a1284b834494d</a:t>
-            </a:r>
-          </a:p>
-          <a:p xmlns:a="http://schemas.openxmlformats.org/drawingml/2006/main">
-            <a:r>
-              <a:t>Speaking time: 30 seconds planned, not measured.</a:t>
             </a:r>
           </a:p>
         </p:txBody>
@@ -994,11 +979,6 @@
               <a:t>B2 sensitivity source SHA-256: 6c79de033666a5f9af5bdcf18222a761b186bf6404ac566d7b7a1284b834494d</a:t>
             </a:r>
           </a:p>
-          <a:p xmlns:a="http://schemas.openxmlformats.org/drawingml/2006/main">
-            <a:r>
-              <a:t>Speaking time: 35 seconds planned, not measured.</a:t>
-            </a:r>
-          </a:p>
         </p:txBody>
       </p:sp>
       <p:sp>
@@ -1101,11 +1081,6 @@
           </a:p>
           <a:p xmlns:a="http://schemas.openxmlformats.org/drawingml/2006/main">
             <a:r>
-              <a:t>Speaking time: 45 seconds planned, not measured.</a:t>
-            </a:r>
-          </a:p>
-          <a:p xmlns:a="http://schemas.openxmlformats.org/drawingml/2006/main">
-            <a:r>
               <a:t>Chart workbook stores six-decimal presentation values; source analysis retains full saved-trace precision. Labels show three decimals.</a:t>
             </a:r>
           </a:p>
@@ -1209,11 +1184,6 @@
               <a:t>B2 sensitivity source SHA-256: 6c79de033666a5f9af5bdcf18222a761b186bf6404ac566d7b7a1284b834494d</a:t>
             </a:r>
           </a:p>
-          <a:p xmlns:a="http://schemas.openxmlformats.org/drawingml/2006/main">
-            <a:r>
-              <a:t>Speaking time: 30 seconds planned, not measured.</a:t>
-            </a:r>
-          </a:p>
         </p:txBody>
       </p:sp>
       <p:sp>
@@ -1314,11 +1284,6 @@
               <a:t>B2 sensitivity source SHA-256: 6c79de033666a5f9af5bdcf18222a761b186bf6404ac566d7b7a1284b834494d</a:t>
             </a:r>
           </a:p>
-          <a:p xmlns:a="http://schemas.openxmlformats.org/drawingml/2006/main">
-            <a:r>
-              <a:t>Speaking time: 25 seconds planned, not measured.</a:t>
-            </a:r>
-          </a:p>
         </p:txBody>
       </p:sp>
       <p:sp>
@@ -1386,7 +1351,7 @@
           <a:lstStyle xmlns:a="http://schemas.openxmlformats.org/drawingml/2006/main"/>
           <a:p xmlns:a="http://schemas.openxmlformats.org/drawingml/2006/main">
             <a:r>
-              <a:t>For an analyst role, I would emphasize metric definitions, reproducible calculations and explaining what evidence supports. The potential use is reviewing generated reports before a business decision, not a claim that I have deployed a control or measured savings. AI assistance is part of the provenance. My next learning step is to explain and modify the analysis directly, supported by a small SQL and BI companion project.</a:t>
+              <a:t>The next implementation targets product rankings. It will use the question, generated answer, metric contract and evidence rows to return a support decision, evidence reference and abstention when needed. Gold answers and evaluation labels stay outside prediction. Two independent reviewers will establish relation labels. The comparison will report extraction coverage and abstentions, because a checker can appear accurate by avoiding difficult claims. This verifier is proposed work, not a completed result.</a:t>
             </a:r>
           </a:p>
           <a:p xmlns:a="http://schemas.openxmlformats.org/drawingml/2006/main">
@@ -1401,12 +1366,12 @@
           </a:p>
           <a:p xmlns:a="http://schemas.openxmlformats.org/drawingml/2006/main">
             <a:r>
-              <a:t>https://github.com/Yuchi-Wang02/bizhallu/blob/main/configs/business_metric_contract_v1_1.json</a:t>
-            </a:r>
-          </a:p>
-          <a:p xmlns:a="http://schemas.openxmlformats.org/drawingml/2006/main">
-            <a:r>
-              <a:t>https://github.com/Yuchi-Wang02/bizhallu/blob/main/reports/bizhallu_statistics_v2_report.json</a:t>
+              <a:t>https://github.com/Yuchi-Wang02/bizhallu/blob/main/configs/relation_annotation_v2.json</a:t>
+            </a:r>
+          </a:p>
+          <a:p xmlns:a="http://schemas.openxmlformats.org/drawingml/2006/main">
+            <a:r>
+              <a:t>https://github.com/Yuchi-Wang02/bizhallu/blob/main/configs/confirmation_set_v1_protocol.json</a:t>
             </a:r>
           </a:p>
           <a:p xmlns:a="http://schemas.openxmlformats.org/drawingml/2006/main">
@@ -1417,11 +1382,6 @@
           <a:p xmlns:a="http://schemas.openxmlformats.org/drawingml/2006/main">
             <a:r>
               <a:t>B2 sensitivity source SHA-256: 6c79de033666a5f9af5bdcf18222a761b186bf6404ac566d7b7a1284b834494d</a:t>
-            </a:r>
-          </a:p>
-          <a:p xmlns:a="http://schemas.openxmlformats.org/drawingml/2006/main">
-            <a:r>
-              <a:t>Speaking time: 25 seconds planned, not measured.</a:t>
             </a:r>
           </a:p>
         </p:txBody>
@@ -1489,7 +1449,7 @@
   </p:cSld>
   <p:clrMap bg1="lt1" tx1="dk1" bg2="lt2" tx2="dk2" accent1="accent1" accent2="accent2" accent3="accent3" accent4="accent4" accent5="accent5" accent6="accent6" hlink="hlink" folHlink="folHlink"/>
   <p:sldLayoutIdLst>
-    <p:sldLayoutId xmlns:r="http://schemas.openxmlformats.org/officeDocument/2006/relationships" id="2147483649" r:id="Ra828c075aac7457e"/>
+    <p:sldLayoutId xmlns:r="http://schemas.openxmlformats.org/officeDocument/2006/relationships" id="2147483649" r:id="R0919d98eecfd4943"/>
   </p:sldLayoutIdLst>
   <p:txStyles>
     <p:titleStyle>
@@ -2336,7 +2296,7 @@
           <p:cNvPr id="6" name="">
             <a:extLst xmlns:a="http://schemas.openxmlformats.org/drawingml/2006/main">
               <a:ext uri="{FF2B5EF4-FFF2-40B4-BE49-F238E27FC236}">
-                <a16:creationId xmlns:a16="http://schemas.microsoft.com/office/drawing/2014/main" id="{7BBDB340-BB17-4FDF-8BBE-43D5338BEF7B}"/>
+                <a16:creationId xmlns:a16="http://schemas.microsoft.com/office/drawing/2014/main" id="{A9B7E305-3ACE-4B79-B545-C0C1C44033F4}"/>
               </a:ext>
             </a:extLst>
           </p:cNvPr>
@@ -2393,7 +2353,7 @@
           <p:cNvPr id="2" name="">
             <a:extLst xmlns:a="http://schemas.openxmlformats.org/drawingml/2006/main">
               <a:ext uri="{FF2B5EF4-FFF2-40B4-BE49-F238E27FC236}">
-                <a16:creationId xmlns:a16="http://schemas.microsoft.com/office/drawing/2014/main" id="{B32408CA-A998-4284-9F80-FAF4ADE43949}"/>
+                <a16:creationId xmlns:a16="http://schemas.microsoft.com/office/drawing/2014/main" id="{E60EAD77-6159-4AEE-9E07-2B32407A2ED6}"/>
               </a:ext>
             </a:extLst>
           </p:cNvPr>
@@ -2440,7 +2400,7 @@
                 <a:ea typeface="Arial"/>
                 <a:cs typeface="Arial"/>
               </a:rPr>
-              <a:t>Business analytics with evidence checks for AI-generated analysis</a:t>
+              <a:t>Auditing AI-generated business analysis against transaction evidence</a:t>
             </a:r>
           </a:p>
         </p:txBody>
@@ -2450,7 +2410,7 @@
           <p:cNvPr id="3" name="">
             <a:extLst xmlns:a="http://schemas.openxmlformats.org/drawingml/2006/main">
               <a:ext uri="{FF2B5EF4-FFF2-40B4-BE49-F238E27FC236}">
-                <a16:creationId xmlns:a16="http://schemas.microsoft.com/office/drawing/2014/main" id="{834E8E83-BA0A-455F-AFB1-7CD53ACA7C0E}"/>
+                <a16:creationId xmlns:a16="http://schemas.microsoft.com/office/drawing/2014/main" id="{022A5DC0-CD65-4555-94C1-630F2EBD2C0B}"/>
               </a:ext>
             </a:extLst>
           </p:cNvPr>
@@ -2461,8 +2421,8 @@
         </p:nvSpPr>
         <p:spPr>
           <a:xfrm xmlns:a="http://schemas.openxmlformats.org/drawingml/2006/main">
-            <a:off x="628650" y="4238625"/>
-            <a:ext cx="10477500" cy="571500"/>
+            <a:off x="628650" y="4191000"/>
+            <a:ext cx="10477500" cy="704850"/>
           </a:xfrm>
           <a:prstGeom xmlns:a="http://schemas.openxmlformats.org/drawingml/2006/main" prst="rect">
             <a:avLst/>
@@ -2497,7 +2457,30 @@
                 <a:ea typeface="Arial"/>
                 <a:cs typeface="Arial"/>
               </a:rPr>
-              <a:t>Yuchi Wang | Accounting and supply management | JHU Carey BAAI</a:t>
+              <a:t>Yuchi Wang</a:t>
+            </a:r>
+          </a:p>
+          <a:p xmlns:a="http://schemas.openxmlformats.org/drawingml/2006/main">
+            <a:pPr>
+              <a:defRPr sz="1800" b="0">
+                <a:solidFill>
+                  <a:srgbClr val="52616B"/>
+                </a:solidFill>
+                <a:latin typeface="Arial"/>
+                <a:ea typeface="Arial"/>
+                <a:cs typeface="Arial"/>
+              </a:defRPr>
+            </a:pPr>
+            <a:r>
+              <a:rPr sz="1800" b="0">
+                <a:solidFill>
+                  <a:srgbClr val="52616B"/>
+                </a:solidFill>
+                <a:latin typeface="Arial"/>
+                <a:ea typeface="Arial"/>
+                <a:cs typeface="Arial"/>
+              </a:rPr>
+              <a:t>Accounting and supply management</a:t>
             </a:r>
           </a:p>
         </p:txBody>
@@ -2507,7 +2490,7 @@
           <p:cNvPr id="4" name="">
             <a:extLst xmlns:a="http://schemas.openxmlformats.org/drawingml/2006/main">
               <a:ext uri="{FF2B5EF4-FFF2-40B4-BE49-F238E27FC236}">
-                <a16:creationId xmlns:a16="http://schemas.microsoft.com/office/drawing/2014/main" id="{58CFAC01-39DF-47E7-8993-F17BE124E8FF}"/>
+                <a16:creationId xmlns:a16="http://schemas.microsoft.com/office/drawing/2014/main" id="{8FFBD413-C5AE-4222-8A2C-AF55F8E190E4}"/>
               </a:ext>
             </a:extLst>
           </p:cNvPr>
@@ -2518,7 +2501,7 @@
         </p:nvSpPr>
         <p:spPr>
           <a:xfrm xmlns:a="http://schemas.openxmlformats.org/drawingml/2006/main">
-            <a:off x="628650" y="5029200"/>
+            <a:off x="628650" y="5353050"/>
             <a:ext cx="10001250" cy="400050"/>
           </a:xfrm>
           <a:prstGeom xmlns:a="http://schemas.openxmlformats.org/drawingml/2006/main" prst="rect">
@@ -2554,7 +2537,7 @@
                 <a:ea typeface="Arial"/>
                 <a:cs typeface="Arial"/>
               </a:rPr>
-              <a:t>Exploratory portfolio study</a:t>
+              <a:t>Exploratory study of fact spans and business relationships</a:t>
             </a:r>
           </a:p>
         </p:txBody>
@@ -2564,7 +2547,7 @@
           <p:cNvPr id="5" name="">
             <a:extLst xmlns:a="http://schemas.openxmlformats.org/drawingml/2006/main">
               <a:ext uri="{FF2B5EF4-FFF2-40B4-BE49-F238E27FC236}">
-                <a16:creationId xmlns:a16="http://schemas.microsoft.com/office/drawing/2014/main" id="{AC44F115-7106-493B-8A84-8817183AE101}"/>
+                <a16:creationId xmlns:a16="http://schemas.microsoft.com/office/drawing/2014/main" id="{E7EA8EC9-127A-4E6E-8976-824A8BAE6D5D}"/>
               </a:ext>
             </a:extLst>
           </p:cNvPr>
@@ -2575,8 +2558,8 @@
         </p:nvSpPr>
         <p:spPr>
           <a:xfrm xmlns:a="http://schemas.openxmlformats.org/drawingml/2006/main">
-            <a:off x="609600" y="6524625"/>
-            <a:ext cx="10858500" cy="228600"/>
+            <a:off x="609600" y="6543675"/>
+            <a:ext cx="10858500" cy="209550"/>
           </a:xfrm>
           <a:prstGeom xmlns:a="http://schemas.openxmlformats.org/drawingml/2006/main" prst="rect">
             <a:avLst/>
@@ -2611,7 +2594,7 @@
                 <a:ea typeface="Arial"/>
                 <a:cs typeface="Arial"/>
               </a:rPr>
-              <a:t>01 / 10  |  BizHallu  |  Exploratory study</a:t>
+              <a:t>BizHallu   01 / 10</a:t>
             </a:r>
           </a:p>
         </p:txBody>
@@ -2619,7 +2602,7 @@
     </p:spTree>
     <p:extLst>
       <p:ext uri="{BB962C8B-B14F-4D97-AF65-F5344CB8AC3E}">
-        <p14:creationId xmlns:p14="http://schemas.microsoft.com/office/powerpoint/2010/main" val="619177774"/>
+        <p14:creationId xmlns:p14="http://schemas.microsoft.com/office/powerpoint/2010/main" val="1379479509"/>
       </p:ext>
     </p:extLst>
   </p:cSld>
@@ -2650,7 +2633,7 @@
           <p:cNvPr id="7" name="">
             <a:extLst xmlns:a="http://schemas.openxmlformats.org/drawingml/2006/main">
               <a:ext uri="{FF2B5EF4-FFF2-40B4-BE49-F238E27FC236}">
-                <a16:creationId xmlns:a16="http://schemas.microsoft.com/office/drawing/2014/main" id="{7E07F6E8-B69A-432C-8400-E069FC124685}"/>
+                <a16:creationId xmlns:a16="http://schemas.microsoft.com/office/drawing/2014/main" id="{6DB00F26-5857-4C70-96E7-76C76BC18A3B}"/>
               </a:ext>
             </a:extLst>
           </p:cNvPr>
@@ -2697,7 +2680,7 @@
                 <a:ea typeface="Arial"/>
                 <a:cs typeface="Arial"/>
               </a:rPr>
-              <a:t>Research questions and next steps</a:t>
+              <a:t>A focused discussion with a research mentor</a:t>
             </a:r>
           </a:p>
         </p:txBody>
@@ -2707,7 +2690,7 @@
           <p:cNvPr id="2" name="">
             <a:extLst xmlns:a="http://schemas.openxmlformats.org/drawingml/2006/main">
               <a:ext uri="{FF2B5EF4-FFF2-40B4-BE49-F238E27FC236}">
-                <a16:creationId xmlns:a16="http://schemas.microsoft.com/office/drawing/2014/main" id="{8280600C-8839-4B3E-8965-60A78EBFC734}"/>
+                <a16:creationId xmlns:a16="http://schemas.microsoft.com/office/drawing/2014/main" id="{0AE29B8A-0CD4-4B1E-8A20-44A5C2023253}"/>
               </a:ext>
             </a:extLst>
           </p:cNvPr>
@@ -2754,7 +2737,7 @@
                 <a:ea typeface="Arial"/>
                 <a:cs typeface="Arial"/>
               </a:rPr>
-              <a:t>Calibrate relation labels and independent review</a:t>
+              <a:t>Feedback request: the unit of annotation and a fair comparison design</a:t>
             </a:r>
           </a:p>
         </p:txBody>
@@ -2764,7 +2747,7 @@
           <p:cNvPr id="3" name="">
             <a:extLst xmlns:a="http://schemas.openxmlformats.org/drawingml/2006/main">
               <a:ext uri="{FF2B5EF4-FFF2-40B4-BE49-F238E27FC236}">
-                <a16:creationId xmlns:a16="http://schemas.microsoft.com/office/drawing/2014/main" id="{4A1B0C16-9538-4D0A-82BB-32649CA387A5}"/>
+                <a16:creationId xmlns:a16="http://schemas.microsoft.com/office/drawing/2014/main" id="{2FD4E23A-EE52-4F5A-8810-2F9D70234430}"/>
               </a:ext>
             </a:extLst>
           </p:cNvPr>
@@ -2811,7 +2794,7 @@
                 <a:ea typeface="Arial"/>
                 <a:cs typeface="Arial"/>
               </a:rPr>
-              <a:t>Build a top3 verifier without gold, labels or detector outcomes as prediction inputs</a:t>
+              <a:t>First study: calibrate product-ranking relationships with independent reviewers.</a:t>
             </a:r>
           </a:p>
         </p:txBody>
@@ -2821,7 +2804,7 @@
           <p:cNvPr id="4" name="">
             <a:extLst xmlns:a="http://schemas.openxmlformats.org/drawingml/2006/main">
               <a:ext uri="{FF2B5EF4-FFF2-40B4-BE49-F238E27FC236}">
-                <a16:creationId xmlns:a16="http://schemas.microsoft.com/office/drawing/2014/main" id="{16041C73-D893-458F-B753-2DFC584DAC9C}"/>
+                <a16:creationId xmlns:a16="http://schemas.microsoft.com/office/drawing/2014/main" id="{B084F3A6-9558-404B-8508-078B7A728FC7}"/>
               </a:ext>
             </a:extLst>
           </p:cNvPr>
@@ -2868,7 +2851,7 @@
                 <a:ea typeface="Arial"/>
                 <a:cs typeface="Arial"/>
               </a:rPr>
-              <a:t>Compare information budgets, coverage and costs before expanding methods</a:t>
+              <a:t>Then freeze predictions and evaluate on separated evidence contexts.</a:t>
             </a:r>
           </a:p>
         </p:txBody>
@@ -2878,7 +2861,7 @@
           <p:cNvPr id="5" name="">
             <a:extLst xmlns:a="http://schemas.openxmlformats.org/drawingml/2006/main">
               <a:ext uri="{FF2B5EF4-FFF2-40B4-BE49-F238E27FC236}">
-                <a16:creationId xmlns:a16="http://schemas.microsoft.com/office/drawing/2014/main" id="{3A91D5F4-A149-4186-8C5B-0182E26FE7A1}"/>
+                <a16:creationId xmlns:a16="http://schemas.microsoft.com/office/drawing/2014/main" id="{748FBBC5-E174-4224-9C06-D092D55D52E0}"/>
               </a:ext>
             </a:extLst>
           </p:cNvPr>
@@ -2925,7 +2908,7 @@
                 <a:ea typeface="Arial"/>
                 <a:cs typeface="Arial"/>
               </a:rPr>
-              <a:t>Feedback request: annotation unit and comparison design</a:t>
+              <a:t>The 48-context confirmation design remains unexecuted and estimation-focused.</a:t>
             </a:r>
           </a:p>
         </p:txBody>
@@ -2935,7 +2918,7 @@
           <p:cNvPr id="6" name="">
             <a:extLst xmlns:a="http://schemas.openxmlformats.org/drawingml/2006/main">
               <a:ext uri="{FF2B5EF4-FFF2-40B4-BE49-F238E27FC236}">
-                <a16:creationId xmlns:a16="http://schemas.microsoft.com/office/drawing/2014/main" id="{E024F14D-B804-4C44-85C0-8C3829DF8D7A}"/>
+                <a16:creationId xmlns:a16="http://schemas.microsoft.com/office/drawing/2014/main" id="{3CF75F88-37F6-4851-B4E7-E9801A43DF96}"/>
               </a:ext>
             </a:extLst>
           </p:cNvPr>
@@ -2946,8 +2929,8 @@
         </p:nvSpPr>
         <p:spPr>
           <a:xfrm xmlns:a="http://schemas.openxmlformats.org/drawingml/2006/main">
-            <a:off x="609600" y="6524625"/>
-            <a:ext cx="10858500" cy="228600"/>
+            <a:off x="609600" y="6543675"/>
+            <a:ext cx="10858500" cy="209550"/>
           </a:xfrm>
           <a:prstGeom xmlns:a="http://schemas.openxmlformats.org/drawingml/2006/main" prst="rect">
             <a:avLst/>
@@ -2982,7 +2965,7 @@
                 <a:ea typeface="Arial"/>
                 <a:cs typeface="Arial"/>
               </a:rPr>
-              <a:t>10 / 10  |  BizHallu  |  Exploratory study</a:t>
+              <a:t>BizHallu   10 / 10</a:t>
             </a:r>
           </a:p>
         </p:txBody>
@@ -2990,7 +2973,7 @@
     </p:spTree>
     <p:extLst>
       <p:ext uri="{BB962C8B-B14F-4D97-AF65-F5344CB8AC3E}">
-        <p14:creationId xmlns:p14="http://schemas.microsoft.com/office/powerpoint/2010/main" val="801742822"/>
+        <p14:creationId xmlns:p14="http://schemas.microsoft.com/office/powerpoint/2010/main" val="1342960785"/>
       </p:ext>
     </p:extLst>
   </p:cSld>
@@ -3021,7 +3004,7 @@
           <p:cNvPr id="6" name="">
             <a:extLst xmlns:a="http://schemas.openxmlformats.org/drawingml/2006/main">
               <a:ext uri="{FF2B5EF4-FFF2-40B4-BE49-F238E27FC236}">
-                <a16:creationId xmlns:a16="http://schemas.microsoft.com/office/drawing/2014/main" id="{9B6B1886-B2CB-4943-B20F-7770A8AD495F}"/>
+                <a16:creationId xmlns:a16="http://schemas.microsoft.com/office/drawing/2014/main" id="{7B7B15A3-88EA-4BA9-AFA4-32DE474A259B}"/>
               </a:ext>
             </a:extLst>
           </p:cNvPr>
@@ -3068,7 +3051,7 @@
                 <a:ea typeface="Arial"/>
                 <a:cs typeface="Arial"/>
               </a:rPr>
-              <a:t>April product ranking</a:t>
+              <a:t>April: a correct amount with an incorrect rank</a:t>
             </a:r>
           </a:p>
         </p:txBody>
@@ -3078,7 +3061,7 @@
           <p:cNvPr id="2" name="">
             <a:extLst xmlns:a="http://schemas.openxmlformats.org/drawingml/2006/main">
               <a:ext uri="{FF2B5EF4-FFF2-40B4-BE49-F238E27FC236}">
-                <a16:creationId xmlns:a16="http://schemas.microsoft.com/office/drawing/2014/main" id="{CC4E7157-856F-4BC5-90CD-E4A2ABE9F909}"/>
+                <a16:creationId xmlns:a16="http://schemas.microsoft.com/office/drawing/2014/main" id="{B39CF087-4F3E-41C7-8DEF-162D723591DD}"/>
               </a:ext>
             </a:extLst>
           </p:cNvPr>
@@ -3090,7 +3073,7 @@
         <p:spPr>
           <a:xfrm xmlns:a="http://schemas.openxmlformats.org/drawingml/2006/main">
             <a:off x="609600" y="1428750"/>
-            <a:ext cx="10972800" cy="609600"/>
+            <a:ext cx="10972800" cy="514350"/>
           </a:xfrm>
           <a:prstGeom xmlns:a="http://schemas.openxmlformats.org/drawingml/2006/main" prst="rect">
             <a:avLst/>
@@ -3107,7 +3090,7 @@
           <a:lstStyle xmlns:a="http://schemas.openxmlformats.org/drawingml/2006/main"/>
           <a:p xmlns:a="http://schemas.openxmlformats.org/drawingml/2006/main">
             <a:pPr>
-              <a:defRPr sz="1950" b="1">
+              <a:defRPr sz="1875" b="1">
                 <a:solidFill>
                   <a:srgbClr val="A13238"/>
                 </a:solidFill>
@@ -3117,7 +3100,7 @@
               </a:defRPr>
             </a:pPr>
             <a:r>
-              <a:rPr sz="1950" b="1">
+              <a:rPr sz="1875" b="1">
                 <a:solidFill>
                   <a:srgbClr val="A13238"/>
                 </a:solidFill>
@@ -3125,7 +3108,7 @@
                 <a:ea typeface="Arial"/>
                 <a:cs typeface="Arial"/>
               </a:rPr>
-              <a:t>Qwen: rank 3 | WOODEN UNION JACK BUNTING | GBP 4,173.18</a:t>
+              <a:t>Qwen assigns rank 3 to WOODEN UNION JACK BUNTING at GBP 4,173.18</a:t>
             </a:r>
           </a:p>
         </p:txBody>
@@ -3398,9 +3381,9 @@
                     <a:lstStyle/>
                     <a:p>
                       <a:r>
-                        <a:rPr sz="1725" b="0">
+                        <a:rPr sz="1725" b="1">
                           <a:solidFill>
-                            <a:srgbClr val="202124"/>
+                            <a:srgbClr val="18765E"/>
                           </a:solidFill>
                           <a:latin typeface="Arial"/>
                           <a:ea typeface="Arial"/>
@@ -3412,7 +3395,7 @@
                   </a:txBody>
                   <a:tcPr marL="91440" marR="91440" marT="45720" marB="45720">
                     <a:solidFill>
-                      <a:srgbClr val="FFFFFF"/>
+                      <a:srgbClr val="EAF5F1"/>
                     </a:solidFill>
                   </a:tcPr>
                 </a:tc>
@@ -3424,9 +3407,9 @@
                     <a:lstStyle/>
                     <a:p>
                       <a:r>
-                        <a:rPr sz="1725" b="0">
+                        <a:rPr sz="1725" b="1">
                           <a:solidFill>
-                            <a:srgbClr val="202124"/>
+                            <a:srgbClr val="18765E"/>
                           </a:solidFill>
                           <a:latin typeface="Arial"/>
                           <a:ea typeface="Arial"/>
@@ -3438,7 +3421,7 @@
                   </a:txBody>
                   <a:tcPr marL="91440" marR="91440" marT="45720" marB="45720">
                     <a:solidFill>
-                      <a:srgbClr val="FFFFFF"/>
+                      <a:srgbClr val="EAF5F1"/>
                     </a:solidFill>
                   </a:tcPr>
                 </a:tc>
@@ -3450,9 +3433,9 @@
                     <a:lstStyle/>
                     <a:p>
                       <a:r>
-                        <a:rPr sz="1725" b="0">
+                        <a:rPr sz="1725" b="1">
                           <a:solidFill>
-                            <a:srgbClr val="202124"/>
+                            <a:srgbClr val="18765E"/>
                           </a:solidFill>
                           <a:latin typeface="Arial"/>
                           <a:ea typeface="Arial"/>
@@ -3464,7 +3447,7 @@
                   </a:txBody>
                   <a:tcPr marL="91440" marR="91440" marT="45720" marB="45720">
                     <a:solidFill>
-                      <a:srgbClr val="FFFFFF"/>
+                      <a:srgbClr val="EAF5F1"/>
                     </a:solidFill>
                   </a:tcPr>
                 </a:tc>
@@ -3718,9 +3701,9 @@
                     <a:lstStyle/>
                     <a:p>
                       <a:r>
-                        <a:rPr sz="1725" b="0">
+                        <a:rPr sz="1725" b="1">
                           <a:solidFill>
-                            <a:srgbClr val="202124"/>
+                            <a:srgbClr val="A13238"/>
                           </a:solidFill>
                           <a:latin typeface="Arial"/>
                           <a:ea typeface="Arial"/>
@@ -3732,7 +3715,7 @@
                   </a:txBody>
                   <a:tcPr marL="91440" marR="91440" marT="45720" marB="45720">
                     <a:solidFill>
-                      <a:srgbClr val="FFFFFF"/>
+                      <a:srgbClr val="FCEDEF"/>
                     </a:solidFill>
                   </a:tcPr>
                 </a:tc>
@@ -3744,9 +3727,9 @@
                     <a:lstStyle/>
                     <a:p>
                       <a:r>
-                        <a:rPr sz="1725" b="0">
+                        <a:rPr sz="1725" b="1">
                           <a:solidFill>
-                            <a:srgbClr val="202124"/>
+                            <a:srgbClr val="A13238"/>
                           </a:solidFill>
                           <a:latin typeface="Arial"/>
                           <a:ea typeface="Arial"/>
@@ -3758,7 +3741,7 @@
                   </a:txBody>
                   <a:tcPr marL="91440" marR="91440" marT="45720" marB="45720">
                     <a:solidFill>
-                      <a:srgbClr val="FFFFFF"/>
+                      <a:srgbClr val="FCEDEF"/>
                     </a:solidFill>
                   </a:tcPr>
                 </a:tc>
@@ -3770,9 +3753,9 @@
                     <a:lstStyle/>
                     <a:p>
                       <a:r>
-                        <a:rPr sz="1725" b="0">
+                        <a:rPr sz="1725" b="1">
                           <a:solidFill>
-                            <a:srgbClr val="202124"/>
+                            <a:srgbClr val="A13238"/>
                           </a:solidFill>
                           <a:latin typeface="Arial"/>
                           <a:ea typeface="Arial"/>
@@ -3784,7 +3767,7 @@
                   </a:txBody>
                   <a:tcPr marL="91440" marR="91440" marT="45720" marB="45720">
                     <a:solidFill>
-                      <a:srgbClr val="FFFFFF"/>
+                      <a:srgbClr val="FCEDEF"/>
                     </a:solidFill>
                   </a:tcPr>
                 </a:tc>
@@ -3878,7 +3861,7 @@
           <p:cNvPr id="4" name="">
             <a:extLst xmlns:a="http://schemas.openxmlformats.org/drawingml/2006/main">
               <a:ext uri="{FF2B5EF4-FFF2-40B4-BE49-F238E27FC236}">
-                <a16:creationId xmlns:a16="http://schemas.microsoft.com/office/drawing/2014/main" id="{1C591BDB-E7E6-45AF-A415-A54212FB7AE1}"/>
+                <a16:creationId xmlns:a16="http://schemas.microsoft.com/office/drawing/2014/main" id="{07DD3883-B1CA-4BD8-AFA4-8EF3B329CE56}"/>
               </a:ext>
             </a:extLst>
           </p:cNvPr>
@@ -3925,7 +3908,7 @@
                 <a:ea typeface="Arial"/>
                 <a:cs typeface="Arial"/>
               </a:rPr>
-              <a:t>Display sorted by net value; original prompt order is preserved in the demo.</a:t>
+              <a:t>Eight evidence rows, sorted here for comparison. The demo preserves original prompt order.</a:t>
             </a:r>
           </a:p>
           <a:p xmlns:a="http://schemas.openxmlformats.org/drawingml/2006/main">
@@ -3948,7 +3931,7 @@
                 <a:ea typeface="Arial"/>
                 <a:cs typeface="Arial"/>
               </a:rPr>
-              <a:t>Product-amount match; actual rank 7, not 3 (eight shown rows).</a:t>
+              <a:t>The copied amount matches its product. Six products have larger values.</a:t>
             </a:r>
           </a:p>
         </p:txBody>
@@ -3958,7 +3941,7 @@
           <p:cNvPr id="5" name="">
             <a:extLst xmlns:a="http://schemas.openxmlformats.org/drawingml/2006/main">
               <a:ext uri="{FF2B5EF4-FFF2-40B4-BE49-F238E27FC236}">
-                <a16:creationId xmlns:a16="http://schemas.microsoft.com/office/drawing/2014/main" id="{CF5BC72B-6BBA-4557-A638-BE0601084734}"/>
+                <a16:creationId xmlns:a16="http://schemas.microsoft.com/office/drawing/2014/main" id="{A18D4B10-769C-4AA1-A450-264E113AF2F2}"/>
               </a:ext>
             </a:extLst>
           </p:cNvPr>
@@ -3969,8 +3952,8 @@
         </p:nvSpPr>
         <p:spPr>
           <a:xfrm xmlns:a="http://schemas.openxmlformats.org/drawingml/2006/main">
-            <a:off x="609600" y="6524625"/>
-            <a:ext cx="10858500" cy="228600"/>
+            <a:off x="609600" y="6543675"/>
+            <a:ext cx="10858500" cy="209550"/>
           </a:xfrm>
           <a:prstGeom xmlns:a="http://schemas.openxmlformats.org/drawingml/2006/main" prst="rect">
             <a:avLst/>
@@ -4005,7 +3988,7 @@
                 <a:ea typeface="Arial"/>
                 <a:cs typeface="Arial"/>
               </a:rPr>
-              <a:t>02 / 10  |  BizHallu  |  Exploratory study</a:t>
+              <a:t>BizHallu   02 / 10</a:t>
             </a:r>
           </a:p>
         </p:txBody>
@@ -4013,7 +3996,7 @@
     </p:spTree>
     <p:extLst>
       <p:ext uri="{BB962C8B-B14F-4D97-AF65-F5344CB8AC3E}">
-        <p14:creationId xmlns:p14="http://schemas.microsoft.com/office/powerpoint/2010/main" val="1293562189"/>
+        <p14:creationId xmlns:p14="http://schemas.microsoft.com/office/powerpoint/2010/main" val="389260341"/>
       </p:ext>
     </p:extLst>
   </p:cSld>
@@ -4044,7 +4027,7 @@
           <p:cNvPr id="6" name="">
             <a:extLst xmlns:a="http://schemas.openxmlformats.org/drawingml/2006/main">
               <a:ext uri="{FF2B5EF4-FFF2-40B4-BE49-F238E27FC236}">
-                <a16:creationId xmlns:a16="http://schemas.microsoft.com/office/drawing/2014/main" id="{3D2E6840-6E5B-4BAF-8258-B4EA33A7D210}"/>
+                <a16:creationId xmlns:a16="http://schemas.microsoft.com/office/drawing/2014/main" id="{9D43983B-A543-48CA-8230-36AAB9DAF542}"/>
               </a:ext>
             </a:extLst>
           </p:cNvPr>
@@ -4091,7 +4074,7 @@
                 <a:ea typeface="Arial"/>
                 <a:cs typeface="Arial"/>
               </a:rPr>
-              <a:t>September: all three ranks differ</a:t>
+              <a:t>September: the same relationship error</a:t>
             </a:r>
           </a:p>
         </p:txBody>
@@ -4101,7 +4084,7 @@
           <p:cNvPr id="2" name="">
             <a:extLst xmlns:a="http://schemas.openxmlformats.org/drawingml/2006/main">
               <a:ext uri="{FF2B5EF4-FFF2-40B4-BE49-F238E27FC236}">
-                <a16:creationId xmlns:a16="http://schemas.microsoft.com/office/drawing/2014/main" id="{4D79B985-CF02-4698-B933-3FD6B6913441}"/>
+                <a16:creationId xmlns:a16="http://schemas.microsoft.com/office/drawing/2014/main" id="{D4947BF6-B7B2-48CD-83DF-4CA982479434}"/>
               </a:ext>
             </a:extLst>
           </p:cNvPr>
@@ -4366,9 +4349,9 @@
                     <a:lstStyle/>
                     <a:p>
                       <a:r>
-                        <a:rPr sz="1725" b="0">
+                        <a:rPr sz="1950" b="1">
                           <a:solidFill>
-                            <a:srgbClr val="202124"/>
+                            <a:srgbClr val="A13238"/>
                           </a:solidFill>
                           <a:latin typeface="Arial"/>
                           <a:ea typeface="Arial"/>
@@ -4472,9 +4455,9 @@
                     <a:lstStyle/>
                     <a:p>
                       <a:r>
-                        <a:rPr sz="1725" b="0">
+                        <a:rPr sz="1950" b="1">
                           <a:solidFill>
-                            <a:srgbClr val="202124"/>
+                            <a:srgbClr val="A13238"/>
                           </a:solidFill>
                           <a:latin typeface="Arial"/>
                           <a:ea typeface="Arial"/>
@@ -4578,9 +4561,9 @@
                     <a:lstStyle/>
                     <a:p>
                       <a:r>
-                        <a:rPr sz="1725" b="0">
+                        <a:rPr sz="1950" b="1">
                           <a:solidFill>
-                            <a:srgbClr val="202124"/>
+                            <a:srgbClr val="A13238"/>
                           </a:solidFill>
                           <a:latin typeface="Arial"/>
                           <a:ea typeface="Arial"/>
@@ -4606,7 +4589,7 @@
           <p:cNvPr id="4" name="">
             <a:extLst xmlns:a="http://schemas.openxmlformats.org/drawingml/2006/main">
               <a:ext uri="{FF2B5EF4-FFF2-40B4-BE49-F238E27FC236}">
-                <a16:creationId xmlns:a16="http://schemas.microsoft.com/office/drawing/2014/main" id="{60774C3A-FD47-4A8A-9258-B881F2640C26}"/>
+                <a16:creationId xmlns:a16="http://schemas.microsoft.com/office/drawing/2014/main" id="{BA1234DE-24B1-4831-9544-3A84ADBFB68F}"/>
               </a:ext>
             </a:extLst>
           </p:cNvPr>
@@ -4663,7 +4646,7 @@
           <p:cNvPr id="5" name="">
             <a:extLst xmlns:a="http://schemas.openxmlformats.org/drawingml/2006/main">
               <a:ext uri="{FF2B5EF4-FFF2-40B4-BE49-F238E27FC236}">
-                <a16:creationId xmlns:a16="http://schemas.microsoft.com/office/drawing/2014/main" id="{E0470CC6-6583-43DB-B054-F9C9F26B99E6}"/>
+                <a16:creationId xmlns:a16="http://schemas.microsoft.com/office/drawing/2014/main" id="{B4F0B936-C545-4049-8C57-7D687AA98CB1}"/>
               </a:ext>
             </a:extLst>
           </p:cNvPr>
@@ -4674,8 +4657,8 @@
         </p:nvSpPr>
         <p:spPr>
           <a:xfrm xmlns:a="http://schemas.openxmlformats.org/drawingml/2006/main">
-            <a:off x="609600" y="6524625"/>
-            <a:ext cx="10858500" cy="228600"/>
+            <a:off x="609600" y="6543675"/>
+            <a:ext cx="10858500" cy="209550"/>
           </a:xfrm>
           <a:prstGeom xmlns:a="http://schemas.openxmlformats.org/drawingml/2006/main" prst="rect">
             <a:avLst/>
@@ -4710,7 +4693,7 @@
                 <a:ea typeface="Arial"/>
                 <a:cs typeface="Arial"/>
               </a:rPr>
-              <a:t>03 / 10  |  BizHallu  |  Exploratory study</a:t>
+              <a:t>BizHallu   03 / 10</a:t>
             </a:r>
           </a:p>
         </p:txBody>
@@ -4718,7 +4701,7 @@
     </p:spTree>
     <p:extLst>
       <p:ext uri="{BB962C8B-B14F-4D97-AF65-F5344CB8AC3E}">
-        <p14:creationId xmlns:p14="http://schemas.microsoft.com/office/powerpoint/2010/main" val="584248214"/>
+        <p14:creationId xmlns:p14="http://schemas.microsoft.com/office/powerpoint/2010/main" val="835417833"/>
       </p:ext>
     </p:extLst>
   </p:cSld>
@@ -4749,7 +4732,7 @@
           <p:cNvPr id="6" name="">
             <a:extLst xmlns:a="http://schemas.openxmlformats.org/drawingml/2006/main">
               <a:ext uri="{FF2B5EF4-FFF2-40B4-BE49-F238E27FC236}">
-                <a16:creationId xmlns:a16="http://schemas.microsoft.com/office/drawing/2014/main" id="{7BAEBCE5-FCB2-49A8-85F3-52B704887AE2}"/>
+                <a16:creationId xmlns:a16="http://schemas.microsoft.com/office/drawing/2014/main" id="{6DC26EE6-3F68-477E-90BC-FFEF748BED20}"/>
               </a:ext>
             </a:extLst>
           </p:cNvPr>
@@ -4796,7 +4779,7 @@
                 <a:ea typeface="Arial"/>
                 <a:cs typeface="Arial"/>
               </a:rPr>
-              <a:t>Business metric scope</a:t>
+              <a:t>Research question: complete business relationships</a:t>
             </a:r>
           </a:p>
         </p:txBody>
@@ -4806,7 +4789,7 @@
           <p:cNvPr id="2" name="">
             <a:extLst xmlns:a="http://schemas.openxmlformats.org/drawingml/2006/main">
               <a:ext uri="{FF2B5EF4-FFF2-40B4-BE49-F238E27FC236}">
-                <a16:creationId xmlns:a16="http://schemas.microsoft.com/office/drawing/2014/main" id="{C284E75B-7285-44F9-B77C-C3490295D3F6}"/>
+                <a16:creationId xmlns:a16="http://schemas.microsoft.com/office/drawing/2014/main" id="{596E9FAB-67D9-4D3A-B41B-9E38C372CD81}"/>
               </a:ext>
             </a:extLst>
           </p:cNvPr>
@@ -4853,7 +4836,7 @@
                 <a:ea typeface="Arial"/>
                 <a:cs typeface="Arial"/>
               </a:rPr>
-              <a:t>Positive / negative transaction value: sign-based ledger quantities</a:t>
+              <a:t>What do uncertainty signals miss when copied facts form an incorrect relationship?</a:t>
             </a:r>
           </a:p>
         </p:txBody>
@@ -4863,7 +4846,7 @@
           <p:cNvPr id="3" name="">
             <a:extLst xmlns:a="http://schemas.openxmlformats.org/drawingml/2006/main">
               <a:ext uri="{FF2B5EF4-FFF2-40B4-BE49-F238E27FC236}">
-                <a16:creationId xmlns:a16="http://schemas.microsoft.com/office/drawing/2014/main" id="{FC0D9635-A3E0-4F18-ABD8-40787D55E0E1}"/>
+                <a16:creationId xmlns:a16="http://schemas.microsoft.com/office/drawing/2014/main" id="{45F6870F-BE9F-4683-8D4C-F236070BFD99}"/>
               </a:ext>
             </a:extLst>
           </p:cNvPr>
@@ -4910,7 +4893,7 @@
                 <a:ea typeface="Arial"/>
                 <a:cs typeface="Arial"/>
               </a:rPr>
-              <a:t>Negative value can include fees and adjustments; physical returns are not separately verified.</a:t>
+              <a:t>A claim binds a period and product to a metric, amount and rank.</a:t>
             </a:r>
           </a:p>
         </p:txBody>
@@ -4920,7 +4903,7 @@
           <p:cNvPr id="4" name="">
             <a:extLst xmlns:a="http://schemas.openxmlformats.org/drawingml/2006/main">
               <a:ext uri="{FF2B5EF4-FFF2-40B4-BE49-F238E27FC236}">
-                <a16:creationId xmlns:a16="http://schemas.microsoft.com/office/drawing/2014/main" id="{AC5505AD-9B85-40DE-A22C-C62DD92333A2}"/>
+                <a16:creationId xmlns:a16="http://schemas.microsoft.com/office/drawing/2014/main" id="{B4681465-2292-49A1-876B-41B6D150C596}"/>
               </a:ext>
             </a:extLst>
           </p:cNvPr>
@@ -4967,7 +4950,7 @@
                 <a:ea typeface="Arial"/>
                 <a:cs typeface="Arial"/>
               </a:rPr>
-              <a:t>Merchandise scope: stock-code heuristic; historical product grain: code + description</a:t>
+              <a:t>Comparison target: internal uncertainty and an independent evidence checker</a:t>
             </a:r>
           </a:p>
         </p:txBody>
@@ -4977,7 +4960,7 @@
           <p:cNvPr id="5" name="">
             <a:extLst xmlns:a="http://schemas.openxmlformats.org/drawingml/2006/main">
               <a:ext uri="{FF2B5EF4-FFF2-40B4-BE49-F238E27FC236}">
-                <a16:creationId xmlns:a16="http://schemas.microsoft.com/office/drawing/2014/main" id="{A947A3F2-BAE7-46A2-A5AC-C287B96FF2A9}"/>
+                <a16:creationId xmlns:a16="http://schemas.microsoft.com/office/drawing/2014/main" id="{6A9A8A17-8D7C-4499-B356-CECA308D6221}"/>
               </a:ext>
             </a:extLst>
           </p:cNvPr>
@@ -4988,8 +4971,8 @@
         </p:nvSpPr>
         <p:spPr>
           <a:xfrm xmlns:a="http://schemas.openxmlformats.org/drawingml/2006/main">
-            <a:off x="609600" y="6524625"/>
-            <a:ext cx="10858500" cy="228600"/>
+            <a:off x="609600" y="6543675"/>
+            <a:ext cx="10858500" cy="209550"/>
           </a:xfrm>
           <a:prstGeom xmlns:a="http://schemas.openxmlformats.org/drawingml/2006/main" prst="rect">
             <a:avLst/>
@@ -5024,7 +5007,7 @@
                 <a:ea typeface="Arial"/>
                 <a:cs typeface="Arial"/>
               </a:rPr>
-              <a:t>04 / 10  |  BizHallu  |  Exploratory study</a:t>
+              <a:t>BizHallu   04 / 10</a:t>
             </a:r>
           </a:p>
         </p:txBody>
@@ -5032,7 +5015,7 @@
     </p:spTree>
     <p:extLst>
       <p:ext uri="{BB962C8B-B14F-4D97-AF65-F5344CB8AC3E}">
-        <p14:creationId xmlns:p14="http://schemas.microsoft.com/office/powerpoint/2010/main" val="751958661"/>
+        <p14:creationId xmlns:p14="http://schemas.microsoft.com/office/powerpoint/2010/main" val="700233246"/>
       </p:ext>
     </p:extLst>
   </p:cSld>
@@ -5063,7 +5046,7 @@
           <p:cNvPr id="7" name="">
             <a:extLst xmlns:a="http://schemas.openxmlformats.org/drawingml/2006/main">
               <a:ext uri="{FF2B5EF4-FFF2-40B4-BE49-F238E27FC236}">
-                <a16:creationId xmlns:a16="http://schemas.microsoft.com/office/drawing/2014/main" id="{A46950B5-24FB-447B-97D4-AAE775DA6D89}"/>
+                <a16:creationId xmlns:a16="http://schemas.microsoft.com/office/drawing/2014/main" id="{D0269070-BA22-4EF3-B790-51AD0F652355}"/>
               </a:ext>
             </a:extLst>
           </p:cNvPr>
@@ -5110,7 +5093,7 @@
                 <a:ea typeface="Arial"/>
                 <a:cs typeface="Arial"/>
               </a:rPr>
-              <a:t>The historical evaluation pipeline</a:t>
+              <a:t>Historical evaluation and its sample</a:t>
             </a:r>
           </a:p>
         </p:txBody>
@@ -5120,7 +5103,7 @@
           <p:cNvPr id="2" name="">
             <a:extLst xmlns:a="http://schemas.openxmlformats.org/drawingml/2006/main">
               <a:ext uri="{FF2B5EF4-FFF2-40B4-BE49-F238E27FC236}">
-                <a16:creationId xmlns:a16="http://schemas.microsoft.com/office/drawing/2014/main" id="{26B148CA-3913-485C-8BF7-2CB2727D0697}"/>
+                <a16:creationId xmlns:a16="http://schemas.microsoft.com/office/drawing/2014/main" id="{95EE1F80-5040-4FFD-B939-C5F0287F91C1}"/>
               </a:ext>
             </a:extLst>
           </p:cNvPr>
@@ -5167,7 +5150,7 @@
                 <a:ea typeface="Arial"/>
                 <a:cs typeface="Arial"/>
               </a:rPr>
-              <a:t>100 deterministic questions / 7 task types / Qwen3-0.6B</a:t>
+              <a:t>100 deterministic retail questions and local Qwen3-0.6B answers</a:t>
             </a:r>
           </a:p>
         </p:txBody>
@@ -5177,7 +5160,7 @@
           <p:cNvPr id="3" name="">
             <a:extLst xmlns:a="http://schemas.openxmlformats.org/drawingml/2006/main">
               <a:ext uri="{FF2B5EF4-FFF2-40B4-BE49-F238E27FC236}">
-                <a16:creationId xmlns:a16="http://schemas.microsoft.com/office/drawing/2014/main" id="{7CE12258-40E8-45C3-95CE-1B8DF2C78F79}"/>
+                <a16:creationId xmlns:a16="http://schemas.microsoft.com/office/drawing/2014/main" id="{7682EE87-C75D-4FDF-ADA5-996D2291C655}"/>
               </a:ext>
             </a:extLst>
           </p:cNvPr>
@@ -5234,7 +5217,7 @@
           <p:cNvPr id="4" name="">
             <a:extLst xmlns:a="http://schemas.openxmlformats.org/drawingml/2006/main">
               <a:ext uri="{FF2B5EF4-FFF2-40B4-BE49-F238E27FC236}">
-                <a16:creationId xmlns:a16="http://schemas.microsoft.com/office/drawing/2014/main" id="{D0BA23A5-D19C-46D6-8836-D39C7BB67894}"/>
+                <a16:creationId xmlns:a16="http://schemas.microsoft.com/office/drawing/2014/main" id="{E2A08B0F-5608-46DA-A414-25765094BF0D}"/>
               </a:ext>
             </a:extLst>
           </p:cNvPr>
@@ -5281,7 +5264,7 @@
                 <a:ea typeface="Arial"/>
                 <a:cs typeface="Arial"/>
               </a:rPr>
-              <a:t>103 test spans / all 18 test questions; B2 separately assesses omitted dev q_0048</a:t>
+              <a:t>103 test spans across 18 questions, including 61 labeled errors</a:t>
             </a:r>
           </a:p>
         </p:txBody>
@@ -5291,7 +5274,7 @@
           <p:cNvPr id="5" name="">
             <a:extLst xmlns:a="http://schemas.openxmlformats.org/drawingml/2006/main">
               <a:ext uri="{FF2B5EF4-FFF2-40B4-BE49-F238E27FC236}">
-                <a16:creationId xmlns:a16="http://schemas.microsoft.com/office/drawing/2014/main" id="{5F3CCFE6-C51E-4575-825B-9E3992F9A2A4}"/>
+                <a16:creationId xmlns:a16="http://schemas.microsoft.com/office/drawing/2014/main" id="{C9768560-A3A2-4735-B1F0-ABA3E011167D}"/>
               </a:ext>
             </a:extLst>
           </p:cNvPr>
@@ -5338,7 +5321,7 @@
                 <a:ea typeface="Arial"/>
                 <a:cs typeface="Arial"/>
               </a:rPr>
-              <a:t>Evidence &gt; answer &gt; pre-identified spans &gt; saved token scores &gt; evaluation</a:t>
+              <a:t>B2 separately adds 9 provisional atoms from the omitted dev answer</a:t>
             </a:r>
           </a:p>
         </p:txBody>
@@ -5348,7 +5331,7 @@
           <p:cNvPr id="6" name="">
             <a:extLst xmlns:a="http://schemas.openxmlformats.org/drawingml/2006/main">
               <a:ext uri="{FF2B5EF4-FFF2-40B4-BE49-F238E27FC236}">
-                <a16:creationId xmlns:a16="http://schemas.microsoft.com/office/drawing/2014/main" id="{AB4216C3-3EA6-4D71-B157-AFFE6B7AAA76}"/>
+                <a16:creationId xmlns:a16="http://schemas.microsoft.com/office/drawing/2014/main" id="{645C666E-5738-4CF3-9627-F8E0B5161AF0}"/>
               </a:ext>
             </a:extLst>
           </p:cNvPr>
@@ -5359,8 +5342,8 @@
         </p:nvSpPr>
         <p:spPr>
           <a:xfrm xmlns:a="http://schemas.openxmlformats.org/drawingml/2006/main">
-            <a:off x="609600" y="6524625"/>
-            <a:ext cx="10858500" cy="228600"/>
+            <a:off x="609600" y="6543675"/>
+            <a:ext cx="10858500" cy="209550"/>
           </a:xfrm>
           <a:prstGeom xmlns:a="http://schemas.openxmlformats.org/drawingml/2006/main" prst="rect">
             <a:avLst/>
@@ -5395,7 +5378,7 @@
                 <a:ea typeface="Arial"/>
                 <a:cs typeface="Arial"/>
               </a:rPr>
-              <a:t>05 / 10  |  BizHallu  |  Exploratory study</a:t>
+              <a:t>BizHallu   05 / 10</a:t>
             </a:r>
           </a:p>
         </p:txBody>
@@ -5403,7 +5386,7 @@
     </p:spTree>
     <p:extLst>
       <p:ext uri="{BB962C8B-B14F-4D97-AF65-F5344CB8AC3E}">
-        <p14:creationId xmlns:p14="http://schemas.microsoft.com/office/powerpoint/2010/main" val="632353111"/>
+        <p14:creationId xmlns:p14="http://schemas.microsoft.com/office/powerpoint/2010/main" val="1454293917"/>
       </p:ext>
     </p:extLst>
   </p:cSld>
@@ -5434,7 +5417,7 @@
           <p:cNvPr id="10" name="">
             <a:extLst xmlns:a="http://schemas.openxmlformats.org/drawingml/2006/main">
               <a:ext uri="{FF2B5EF4-FFF2-40B4-BE49-F238E27FC236}">
-                <a16:creationId xmlns:a16="http://schemas.microsoft.com/office/drawing/2014/main" id="{19B9A847-1B06-4AB0-9F3C-855F1784524D}"/>
+                <a16:creationId xmlns:a16="http://schemas.microsoft.com/office/drawing/2014/main" id="{BD493E17-3424-49C7-9E1C-F5FA46A3433B}"/>
               </a:ext>
             </a:extLst>
           </p:cNvPr>
@@ -5481,7 +5464,7 @@
                 <a:ea typeface="Arial"/>
                 <a:cs typeface="Arial"/>
               </a:rPr>
-              <a:t>Historical B1 references and B2 sensitivity</a:t>
+              <a:t>The F1 advantage remains uncertain</a:t>
             </a:r>
           </a:p>
         </p:txBody>
@@ -5498,7 +5481,7 @@
         </p:xfrm>
         <a:graphic xmlns:a="http://schemas.openxmlformats.org/drawingml/2006/main">
           <a:graphicData uri="http://schemas.openxmlformats.org/drawingml/2006/chart">
-            <c:chart xmlns:r="http://schemas.openxmlformats.org/officeDocument/2006/relationships" xmlns:c="http://schemas.openxmlformats.org/drawingml/2006/chart" r:id="R218d0d0ec101461d"/>
+            <c:chart xmlns:r="http://schemas.openxmlformats.org/officeDocument/2006/relationships" xmlns:c="http://schemas.openxmlformats.org/drawingml/2006/chart" r:id="Rebce53c98eba4d87"/>
           </a:graphicData>
         </a:graphic>
       </p:graphicFrame>
@@ -5507,7 +5490,7 @@
           <p:cNvPr id="3" name="">
             <a:extLst xmlns:a="http://schemas.openxmlformats.org/drawingml/2006/main">
               <a:ext uri="{FF2B5EF4-FFF2-40B4-BE49-F238E27FC236}">
-                <a16:creationId xmlns:a16="http://schemas.microsoft.com/office/drawing/2014/main" id="{701963F9-BC1E-4E30-BDCD-C8C38A20080A}"/>
+                <a16:creationId xmlns:a16="http://schemas.microsoft.com/office/drawing/2014/main" id="{680C0CDE-DA0D-4FBB-A19F-27B8841CC62E}"/>
               </a:ext>
             </a:extLst>
           </p:cNvPr>
@@ -5564,7 +5547,7 @@
           <p:cNvPr id="4" name="">
             <a:extLst xmlns:a="http://schemas.openxmlformats.org/drawingml/2006/main">
               <a:ext uri="{FF2B5EF4-FFF2-40B4-BE49-F238E27FC236}">
-                <a16:creationId xmlns:a16="http://schemas.microsoft.com/office/drawing/2014/main" id="{1A53AC89-8CA1-4319-9E05-0A561DD3E22B}"/>
+                <a16:creationId xmlns:a16="http://schemas.microsoft.com/office/drawing/2014/main" id="{2F996A39-AC46-4D00-B53D-1C6BD3EACAC6}"/>
               </a:ext>
             </a:extLst>
           </p:cNvPr>
@@ -5621,7 +5604,7 @@
           <p:cNvPr id="5" name="">
             <a:extLst xmlns:a="http://schemas.openxmlformats.org/drawingml/2006/main">
               <a:ext uri="{FF2B5EF4-FFF2-40B4-BE49-F238E27FC236}">
-                <a16:creationId xmlns:a16="http://schemas.microsoft.com/office/drawing/2014/main" id="{89D6FF1B-1BE5-48DA-9491-B66B28FE68AF}"/>
+                <a16:creationId xmlns:a16="http://schemas.microsoft.com/office/drawing/2014/main" id="{6DE215C1-A364-43A2-B2FD-B6733CF097F4}"/>
               </a:ext>
             </a:extLst>
           </p:cNvPr>
@@ -5724,7 +5707,7 @@
           <p:cNvPr id="6" name="">
             <a:extLst xmlns:a="http://schemas.openxmlformats.org/drawingml/2006/main">
               <a:ext uri="{FF2B5EF4-FFF2-40B4-BE49-F238E27FC236}">
-                <a16:creationId xmlns:a16="http://schemas.microsoft.com/office/drawing/2014/main" id="{1A45B832-4D63-47B1-ABC6-51F7D462DDDD}"/>
+                <a16:creationId xmlns:a16="http://schemas.microsoft.com/office/drawing/2014/main" id="{5A3AE44E-BCF7-4A4B-BB30-3137B2D2771C}"/>
               </a:ext>
             </a:extLst>
           </p:cNvPr>
@@ -5781,7 +5764,7 @@
           <p:cNvPr id="7" name="">
             <a:extLst xmlns:a="http://schemas.openxmlformats.org/drawingml/2006/main">
               <a:ext uri="{FF2B5EF4-FFF2-40B4-BE49-F238E27FC236}">
-                <a16:creationId xmlns:a16="http://schemas.microsoft.com/office/drawing/2014/main" id="{17F2092C-D86A-4F16-9020-522DF1AB890D}"/>
+                <a16:creationId xmlns:a16="http://schemas.microsoft.com/office/drawing/2014/main" id="{C8437045-365E-4CC7-AFD8-2D9F500D396E}"/>
               </a:ext>
             </a:extLst>
           </p:cNvPr>
@@ -5838,7 +5821,7 @@
           <p:cNvPr id="8" name="">
             <a:extLst xmlns:a="http://schemas.openxmlformats.org/drawingml/2006/main">
               <a:ext uri="{FF2B5EF4-FFF2-40B4-BE49-F238E27FC236}">
-                <a16:creationId xmlns:a16="http://schemas.microsoft.com/office/drawing/2014/main" id="{8CF64F8C-5BDE-4395-B05A-6DB1D902DF4D}"/>
+                <a16:creationId xmlns:a16="http://schemas.microsoft.com/office/drawing/2014/main" id="{594ACDD8-ADB3-4A51-A224-A8A4A459A85F}"/>
               </a:ext>
             </a:extLst>
           </p:cNvPr>
@@ -5895,7 +5878,7 @@
           <p:cNvPr id="9" name="">
             <a:extLst xmlns:a="http://schemas.openxmlformats.org/drawingml/2006/main">
               <a:ext uri="{FF2B5EF4-FFF2-40B4-BE49-F238E27FC236}">
-                <a16:creationId xmlns:a16="http://schemas.microsoft.com/office/drawing/2014/main" id="{CA28884C-76DA-45E5-93BE-9382E2D03176}"/>
+                <a16:creationId xmlns:a16="http://schemas.microsoft.com/office/drawing/2014/main" id="{69CAEF70-3694-42C8-AD0D-7CE16F63E891}"/>
               </a:ext>
             </a:extLst>
           </p:cNvPr>
@@ -5906,8 +5889,8 @@
         </p:nvSpPr>
         <p:spPr>
           <a:xfrm xmlns:a="http://schemas.openxmlformats.org/drawingml/2006/main">
-            <a:off x="609600" y="6524625"/>
-            <a:ext cx="10858500" cy="228600"/>
+            <a:off x="609600" y="6543675"/>
+            <a:ext cx="10858500" cy="209550"/>
           </a:xfrm>
           <a:prstGeom xmlns:a="http://schemas.openxmlformats.org/drawingml/2006/main" prst="rect">
             <a:avLst/>
@@ -5942,7 +5925,7 @@
                 <a:ea typeface="Arial"/>
                 <a:cs typeface="Arial"/>
               </a:rPr>
-              <a:t>06 / 10  |  BizHallu  |  Exploratory study</a:t>
+              <a:t>BizHallu   06 / 10</a:t>
             </a:r>
           </a:p>
         </p:txBody>
@@ -5950,7 +5933,7 @@
     </p:spTree>
     <p:extLst>
       <p:ext uri="{BB962C8B-B14F-4D97-AF65-F5344CB8AC3E}">
-        <p14:creationId xmlns:p14="http://schemas.microsoft.com/office/powerpoint/2010/main" val="1076616082"/>
+        <p14:creationId xmlns:p14="http://schemas.microsoft.com/office/powerpoint/2010/main" val="1261481319"/>
       </p:ext>
     </p:extLst>
   </p:cSld>
@@ -5981,7 +5964,7 @@
           <p:cNvPr id="7" name="">
             <a:extLst xmlns:a="http://schemas.openxmlformats.org/drawingml/2006/main">
               <a:ext uri="{FF2B5EF4-FFF2-40B4-BE49-F238E27FC236}">
-                <a16:creationId xmlns:a16="http://schemas.microsoft.com/office/drawing/2014/main" id="{D285720D-A086-413C-A6EA-D2FAEF14D73D}"/>
+                <a16:creationId xmlns:a16="http://schemas.microsoft.com/office/drawing/2014/main" id="{9DA96254-C45B-4674-8781-EE71305D6279}"/>
               </a:ext>
             </a:extLst>
           </p:cNvPr>
@@ -6028,7 +6011,7 @@
                 <a:ea typeface="Arial"/>
                 <a:cs typeface="Arial"/>
               </a:rPr>
-              <a:t>Token timing and completed relationships</a:t>
+              <a:t>A fair comparison needs the same information</a:t>
             </a:r>
           </a:p>
         </p:txBody>
@@ -6038,7 +6021,7 @@
           <p:cNvPr id="2" name="">
             <a:extLst xmlns:a="http://schemas.openxmlformats.org/drawingml/2006/main">
               <a:ext uri="{FF2B5EF4-FFF2-40B4-BE49-F238E27FC236}">
-                <a16:creationId xmlns:a16="http://schemas.microsoft.com/office/drawing/2014/main" id="{E2BBCEBD-D458-48C3-8B5F-53290467A106}"/>
+                <a16:creationId xmlns:a16="http://schemas.microsoft.com/office/drawing/2014/main" id="{37F9633D-3287-4F71-AF7E-615CA03E6398}"/>
               </a:ext>
             </a:extLst>
           </p:cNvPr>
@@ -6085,7 +6068,7 @@
                 <a:ea typeface="Arial"/>
                 <a:cs typeface="Arial"/>
               </a:rPr>
-              <a:t>The model generates the list marker before the product and amount.</a:t>
+              <a:t>The list marker appears before its product and amount.</a:t>
             </a:r>
           </a:p>
         </p:txBody>
@@ -6095,7 +6078,7 @@
           <p:cNvPr id="3" name="">
             <a:extLst xmlns:a="http://schemas.openxmlformats.org/drawingml/2006/main">
               <a:ext uri="{FF2B5EF4-FFF2-40B4-BE49-F238E27FC236}">
-                <a16:creationId xmlns:a16="http://schemas.microsoft.com/office/drawing/2014/main" id="{26007211-ED71-4C6C-96CC-0B80D025A9CD}"/>
+                <a16:creationId xmlns:a16="http://schemas.microsoft.com/office/drawing/2014/main" id="{E7C14655-8329-4640-B405-862378296C8C}"/>
               </a:ext>
             </a:extLst>
           </p:cNvPr>
@@ -6142,7 +6125,7 @@
                 <a:ea typeface="Arial"/>
                 <a:cs typeface="Arial"/>
               </a:rPr>
-              <a:t>Low uncertainty on "3." does not establish confidence in the completed relationship.</a:t>
+              <a:t>An early token score cannot judge a relationship that is still incomplete.</a:t>
             </a:r>
           </a:p>
         </p:txBody>
@@ -6152,7 +6135,7 @@
           <p:cNvPr id="4" name="">
             <a:extLst xmlns:a="http://schemas.openxmlformats.org/drawingml/2006/main">
               <a:ext uri="{FF2B5EF4-FFF2-40B4-BE49-F238E27FC236}">
-                <a16:creationId xmlns:a16="http://schemas.microsoft.com/office/drawing/2014/main" id="{70237E9E-421C-4E80-B663-61FFBB2FBF2B}"/>
+                <a16:creationId xmlns:a16="http://schemas.microsoft.com/office/drawing/2014/main" id="{DE53D9C6-CFCF-47F5-A874-1843DE5BAD37}"/>
               </a:ext>
             </a:extLst>
           </p:cNvPr>
@@ -6199,7 +6182,7 @@
                 <a:ea typeface="Arial"/>
                 <a:cs typeface="Arial"/>
               </a:rPr>
-              <a:t>Raw teacher-forced logits are not the sampling distribution.</a:t>
+              <a:t>Compare complete claims at a defined point in the answer.</a:t>
             </a:r>
           </a:p>
         </p:txBody>
@@ -6209,7 +6192,7 @@
           <p:cNvPr id="5" name="">
             <a:extLst xmlns:a="http://schemas.openxmlformats.org/drawingml/2006/main">
               <a:ext uri="{FF2B5EF4-FFF2-40B4-BE49-F238E27FC236}">
-                <a16:creationId xmlns:a16="http://schemas.microsoft.com/office/drawing/2014/main" id="{4AE5B4EC-24D0-4128-8D19-F9CA2BACFEFE}"/>
+                <a16:creationId xmlns:a16="http://schemas.microsoft.com/office/drawing/2014/main" id="{789C19C4-1C54-4062-98C4-9BD097AE3506}"/>
               </a:ext>
             </a:extLst>
           </p:cNvPr>
@@ -6256,7 +6239,7 @@
                 <a:ea typeface="Arial"/>
                 <a:cs typeface="Arial"/>
               </a:rPr>
-              <a:t>Same-step energy gap equals token NLL; residual mass is a probability control.</a:t>
+              <a:t>Saved scores use raw logits. Same-step energy gap equals token NLL.</a:t>
             </a:r>
           </a:p>
         </p:txBody>
@@ -6266,7 +6249,7 @@
           <p:cNvPr id="6" name="">
             <a:extLst xmlns:a="http://schemas.openxmlformats.org/drawingml/2006/main">
               <a:ext uri="{FF2B5EF4-FFF2-40B4-BE49-F238E27FC236}">
-                <a16:creationId xmlns:a16="http://schemas.microsoft.com/office/drawing/2014/main" id="{1DE86660-2D0B-4278-A275-04E738668E22}"/>
+                <a16:creationId xmlns:a16="http://schemas.microsoft.com/office/drawing/2014/main" id="{2428187F-35B3-4CB0-826F-03E8B8DD090C}"/>
               </a:ext>
             </a:extLst>
           </p:cNvPr>
@@ -6277,8 +6260,8 @@
         </p:nvSpPr>
         <p:spPr>
           <a:xfrm xmlns:a="http://schemas.openxmlformats.org/drawingml/2006/main">
-            <a:off x="609600" y="6524625"/>
-            <a:ext cx="10858500" cy="228600"/>
+            <a:off x="609600" y="6543675"/>
+            <a:ext cx="10858500" cy="209550"/>
           </a:xfrm>
           <a:prstGeom xmlns:a="http://schemas.openxmlformats.org/drawingml/2006/main" prst="rect">
             <a:avLst/>
@@ -6313,7 +6296,7 @@
                 <a:ea typeface="Arial"/>
                 <a:cs typeface="Arial"/>
               </a:rPr>
-              <a:t>07 / 10  |  BizHallu  |  Exploratory study</a:t>
+              <a:t>BizHallu   07 / 10</a:t>
             </a:r>
           </a:p>
         </p:txBody>
@@ -6321,7 +6304,7 @@
     </p:spTree>
     <p:extLst>
       <p:ext uri="{BB962C8B-B14F-4D97-AF65-F5344CB8AC3E}">
-        <p14:creationId xmlns:p14="http://schemas.microsoft.com/office/powerpoint/2010/main" val="97785536"/>
+        <p14:creationId xmlns:p14="http://schemas.microsoft.com/office/powerpoint/2010/main" val="1208154026"/>
       </p:ext>
     </p:extLst>
   </p:cSld>
@@ -6352,7 +6335,7 @@
           <p:cNvPr id="6" name="">
             <a:extLst xmlns:a="http://schemas.openxmlformats.org/drawingml/2006/main">
               <a:ext uri="{FF2B5EF4-FFF2-40B4-BE49-F238E27FC236}">
-                <a16:creationId xmlns:a16="http://schemas.microsoft.com/office/drawing/2014/main" id="{7C6578C9-B12B-438E-B65D-466DC1EE1CC2}"/>
+                <a16:creationId xmlns:a16="http://schemas.microsoft.com/office/drawing/2014/main" id="{88E0481C-A1C5-4EFA-8D63-B783FB083BCC}"/>
               </a:ext>
             </a:extLst>
           </p:cNvPr>
@@ -6399,7 +6382,7 @@
                 <a:ea typeface="Arial"/>
                 <a:cs typeface="Arial"/>
               </a:rPr>
-              <a:t>Scope of the evidence</a:t>
+              <a:t>What the current evidence supports</a:t>
             </a:r>
           </a:p>
         </p:txBody>
@@ -6409,7 +6392,7 @@
           <p:cNvPr id="2" name="">
             <a:extLst xmlns:a="http://schemas.openxmlformats.org/drawingml/2006/main">
               <a:ext uri="{FF2B5EF4-FFF2-40B4-BE49-F238E27FC236}">
-                <a16:creationId xmlns:a16="http://schemas.microsoft.com/office/drawing/2014/main" id="{D132306C-67EB-48CE-BC46-AE83E241BAA2}"/>
+                <a16:creationId xmlns:a16="http://schemas.microsoft.com/office/drawing/2014/main" id="{3079390D-B60B-48A0-96A6-E7C4B663E53C}"/>
               </a:ext>
             </a:extLst>
           </p:cNvPr>
@@ -6456,7 +6439,7 @@
                 <a:ea typeface="Arial"/>
                 <a:cs typeface="Arial"/>
               </a:rPr>
-              <a:t>Provisional labels; no independent human agreement</a:t>
+              <a:t>Reproducible exploratory comparisons on provisional fact spans</a:t>
             </a:r>
           </a:p>
         </p:txBody>
@@ -6466,7 +6449,7 @@
           <p:cNvPr id="3" name="">
             <a:extLst xmlns:a="http://schemas.openxmlformats.org/drawingml/2006/main">
               <a:ext uri="{FF2B5EF4-FFF2-40B4-BE49-F238E27FC236}">
-                <a16:creationId xmlns:a16="http://schemas.microsoft.com/office/drawing/2014/main" id="{728F8A96-E2E7-4892-8EE8-B01D200AA464}"/>
+                <a16:creationId xmlns:a16="http://schemas.microsoft.com/office/drawing/2014/main" id="{8C6BC8D8-14A1-424A-B37A-2A7E47733752}"/>
               </a:ext>
             </a:extLst>
           </p:cNvPr>
@@ -6513,7 +6496,7 @@
                 <a:ea typeface="Arial"/>
                 <a:cs typeface="Arial"/>
               </a:rPr>
-              <a:t>Outcome-informed annotation queue; shared business periods and evidence</a:t>
+              <a:t>Answer quality influenced selection. Dev and test share periods and evidence.</a:t>
             </a:r>
           </a:p>
         </p:txBody>
@@ -6523,7 +6506,7 @@
           <p:cNvPr id="4" name="">
             <a:extLst xmlns:a="http://schemas.openxmlformats.org/drawingml/2006/main">
               <a:ext uri="{FF2B5EF4-FFF2-40B4-BE49-F238E27FC236}">
-                <a16:creationId xmlns:a16="http://schemas.microsoft.com/office/drawing/2014/main" id="{26193D91-E0E7-4853-B926-0CFB0659A7CE}"/>
+                <a16:creationId xmlns:a16="http://schemas.microsoft.com/office/drawing/2014/main" id="{275C3645-79C0-4BC3-A023-2A835DA38D49}"/>
               </a:ext>
             </a:extLst>
           </p:cNvPr>
@@ -6570,7 +6553,7 @@
                 <a:ea typeface="Arial"/>
                 <a:cs typeface="Arial"/>
               </a:rPr>
-              <a:t>One small model; pre-identified fact spans; no production performance estimate</a:t>
+              <a:t>Independent human agreement and automatic claim extraction remain open.</a:t>
             </a:r>
           </a:p>
         </p:txBody>
@@ -6580,7 +6563,7 @@
           <p:cNvPr id="5" name="">
             <a:extLst xmlns:a="http://schemas.openxmlformats.org/drawingml/2006/main">
               <a:ext uri="{FF2B5EF4-FFF2-40B4-BE49-F238E27FC236}">
-                <a16:creationId xmlns:a16="http://schemas.microsoft.com/office/drawing/2014/main" id="{8BBC7ED7-ED15-46F1-8AA9-3BF3B85823E5}"/>
+                <a16:creationId xmlns:a16="http://schemas.microsoft.com/office/drawing/2014/main" id="{BA6DE9B3-E5C6-4571-BD5B-1DFD784357A8}"/>
               </a:ext>
             </a:extLst>
           </p:cNvPr>
@@ -6591,8 +6574,8 @@
         </p:nvSpPr>
         <p:spPr>
           <a:xfrm xmlns:a="http://schemas.openxmlformats.org/drawingml/2006/main">
-            <a:off x="609600" y="6524625"/>
-            <a:ext cx="10858500" cy="228600"/>
+            <a:off x="609600" y="6543675"/>
+            <a:ext cx="10858500" cy="209550"/>
           </a:xfrm>
           <a:prstGeom xmlns:a="http://schemas.openxmlformats.org/drawingml/2006/main" prst="rect">
             <a:avLst/>
@@ -6627,7 +6610,7 @@
                 <a:ea typeface="Arial"/>
                 <a:cs typeface="Arial"/>
               </a:rPr>
-              <a:t>08 / 10  |  BizHallu  |  Exploratory study</a:t>
+              <a:t>BizHallu   08 / 10</a:t>
             </a:r>
           </a:p>
         </p:txBody>
@@ -6635,7 +6618,7 @@
     </p:spTree>
     <p:extLst>
       <p:ext uri="{BB962C8B-B14F-4D97-AF65-F5344CB8AC3E}">
-        <p14:creationId xmlns:p14="http://schemas.microsoft.com/office/powerpoint/2010/main" val="2147417203"/>
+        <p14:creationId xmlns:p14="http://schemas.microsoft.com/office/powerpoint/2010/main" val="771196765"/>
       </p:ext>
     </p:extLst>
   </p:cSld>
@@ -6666,7 +6649,7 @@
           <p:cNvPr id="7" name="">
             <a:extLst xmlns:a="http://schemas.openxmlformats.org/drawingml/2006/main">
               <a:ext uri="{FF2B5EF4-FFF2-40B4-BE49-F238E27FC236}">
-                <a16:creationId xmlns:a16="http://schemas.microsoft.com/office/drawing/2014/main" id="{354DE927-7815-4AC8-B840-19FAA5CA628C}"/>
+                <a16:creationId xmlns:a16="http://schemas.microsoft.com/office/drawing/2014/main" id="{554EE766-B7B2-4563-87B4-B2CCFA3B8358}"/>
               </a:ext>
             </a:extLst>
           </p:cNvPr>
@@ -6713,7 +6696,7 @@
                 <a:ea typeface="Arial"/>
                 <a:cs typeface="Arial"/>
               </a:rPr>
-              <a:t>Analyst contribution and business use</a:t>
+              <a:t>Proposed comparison: product-ranking verification</a:t>
             </a:r>
           </a:p>
         </p:txBody>
@@ -6723,7 +6706,7 @@
           <p:cNvPr id="2" name="">
             <a:extLst xmlns:a="http://schemas.openxmlformats.org/drawingml/2006/main">
               <a:ext uri="{FF2B5EF4-FFF2-40B4-BE49-F238E27FC236}">
-                <a16:creationId xmlns:a16="http://schemas.microsoft.com/office/drawing/2014/main" id="{A7511D8D-AE60-4BC3-9C3E-E297161F09A1}"/>
+                <a16:creationId xmlns:a16="http://schemas.microsoft.com/office/drawing/2014/main" id="{0F73CB70-ADD9-45FC-9AE1-9C8ED958C6C9}"/>
               </a:ext>
             </a:extLst>
           </p:cNvPr>
@@ -6770,7 +6753,7 @@
                 <a:ea typeface="Arial"/>
                 <a:cs typeface="Arial"/>
               </a:rPr>
-              <a:t>Project direction with AI-assisted coding and review</a:t>
+              <a:t>Inputs: question, generated answer, metric contract and evidence rows</a:t>
             </a:r>
           </a:p>
         </p:txBody>
@@ -6780,7 +6763,7 @@
           <p:cNvPr id="3" name="">
             <a:extLst xmlns:a="http://schemas.openxmlformats.org/drawingml/2006/main">
               <a:ext uri="{FF2B5EF4-FFF2-40B4-BE49-F238E27FC236}">
-                <a16:creationId xmlns:a16="http://schemas.microsoft.com/office/drawing/2014/main" id="{EFDEA68A-F5A4-471E-A81A-30182BB155D5}"/>
+                <a16:creationId xmlns:a16="http://schemas.microsoft.com/office/drawing/2014/main" id="{7FA09D24-CCAB-4161-A677-C7D105828F38}"/>
               </a:ext>
             </a:extLst>
           </p:cNvPr>
@@ -6827,7 +6810,7 @@
                 <a:ea typeface="Arial"/>
                 <a:cs typeface="Arial"/>
               </a:rPr>
-              <a:t>Auditable metric definitions, traceable evidence and reproducible calculations</a:t>
+              <a:t>Independent output: support status, evidence reference and abstention</a:t>
             </a:r>
           </a:p>
         </p:txBody>
@@ -6837,7 +6820,7 @@
           <p:cNvPr id="4" name="">
             <a:extLst xmlns:a="http://schemas.openxmlformats.org/drawingml/2006/main">
               <a:ext uri="{FF2B5EF4-FFF2-40B4-BE49-F238E27FC236}">
-                <a16:creationId xmlns:a16="http://schemas.microsoft.com/office/drawing/2014/main" id="{66C3D867-072C-4E11-B60E-A9613C8D03F6}"/>
+                <a16:creationId xmlns:a16="http://schemas.microsoft.com/office/drawing/2014/main" id="{7550AC89-F6F5-4BB1-9EBF-7BE4154A26B6}"/>
               </a:ext>
             </a:extLst>
           </p:cNvPr>
@@ -6884,7 +6867,7 @@
                 <a:ea typeface="Arial"/>
                 <a:cs typeface="Arial"/>
               </a:rPr>
-              <a:t>Potential use: review AI-generated reporting before a business decision</a:t>
+              <a:t>Compare with uncertainty on the same complete claims.</a:t>
             </a:r>
           </a:p>
         </p:txBody>
@@ -6894,7 +6877,7 @@
           <p:cNvPr id="5" name="">
             <a:extLst xmlns:a="http://schemas.openxmlformats.org/drawingml/2006/main">
               <a:ext uri="{FF2B5EF4-FFF2-40B4-BE49-F238E27FC236}">
-                <a16:creationId xmlns:a16="http://schemas.microsoft.com/office/drawing/2014/main" id="{4E63CBDD-2140-4F4A-9FE0-2408FD7150BD}"/>
+                <a16:creationId xmlns:a16="http://schemas.microsoft.com/office/drawing/2014/main" id="{A779501D-6340-498D-B597-DC0133F202F3}"/>
               </a:ext>
             </a:extLst>
           </p:cNvPr>
@@ -6941,7 +6924,7 @@
                 <a:ea typeface="Arial"/>
                 <a:cs typeface="Arial"/>
               </a:rPr>
-              <a:t>No measured cost saving, deployed control or verified independent mastery</a:t>
+              <a:t>Report extraction coverage and errors. Evaluation labels stay outside prediction.</a:t>
             </a:r>
           </a:p>
         </p:txBody>
@@ -6951,7 +6934,7 @@
           <p:cNvPr id="6" name="">
             <a:extLst xmlns:a="http://schemas.openxmlformats.org/drawingml/2006/main">
               <a:ext uri="{FF2B5EF4-FFF2-40B4-BE49-F238E27FC236}">
-                <a16:creationId xmlns:a16="http://schemas.microsoft.com/office/drawing/2014/main" id="{EF8529AC-B863-4E6D-8DDE-44A5930CBEE5}"/>
+                <a16:creationId xmlns:a16="http://schemas.microsoft.com/office/drawing/2014/main" id="{2B6A94DC-AFF9-45BD-9B73-F12144D581A1}"/>
               </a:ext>
             </a:extLst>
           </p:cNvPr>
@@ -6962,8 +6945,8 @@
         </p:nvSpPr>
         <p:spPr>
           <a:xfrm xmlns:a="http://schemas.openxmlformats.org/drawingml/2006/main">
-            <a:off x="609600" y="6524625"/>
-            <a:ext cx="10858500" cy="228600"/>
+            <a:off x="609600" y="6543675"/>
+            <a:ext cx="10858500" cy="209550"/>
           </a:xfrm>
           <a:prstGeom xmlns:a="http://schemas.openxmlformats.org/drawingml/2006/main" prst="rect">
             <a:avLst/>
@@ -6998,7 +6981,7 @@
                 <a:ea typeface="Arial"/>
                 <a:cs typeface="Arial"/>
               </a:rPr>
-              <a:t>09 / 10  |  BizHallu  |  Exploratory study</a:t>
+              <a:t>BizHallu   09 / 10</a:t>
             </a:r>
           </a:p>
         </p:txBody>
@@ -7006,7 +6989,7 @@
     </p:spTree>
     <p:extLst>
       <p:ext uri="{BB962C8B-B14F-4D97-AF65-F5344CB8AC3E}">
-        <p14:creationId xmlns:p14="http://schemas.microsoft.com/office/powerpoint/2010/main" val="592804530"/>
+        <p14:creationId xmlns:p14="http://schemas.microsoft.com/office/powerpoint/2010/main" val="891304097"/>
       </p:ext>
     </p:extLst>
   </p:cSld>

</xml_diff>

<commit_message>
Update author profile to current JHU Carey BAAI student
</commit_message>
<xml_diff>
--- a/docs/assets/bizhallu_interview_v2.pptx
+++ b/docs/assets/bizhallu_interview_v2.pptx
@@ -2,22 +2,22 @@
 <file path=ppt/presentation.xml><?xml version="1.0" encoding="utf-8"?>
 <p:presentation xmlns:p="http://schemas.openxmlformats.org/presentationml/2006/main">
   <p:sldMasterIdLst>
-    <p:sldMasterId xmlns:r="http://schemas.openxmlformats.org/officeDocument/2006/relationships" id="2147483648" r:id="R5fad81ba96214384"/>
+    <p:sldMasterId xmlns:r="http://schemas.openxmlformats.org/officeDocument/2006/relationships" id="2147483648" r:id="Rf739bcc5e7074474"/>
   </p:sldMasterIdLst>
   <p:notesMasterIdLst>
-    <p:notesMasterId xmlns:r="http://schemas.openxmlformats.org/officeDocument/2006/relationships" r:id="R6ce0562ca9324c9e"/>
+    <p:notesMasterId xmlns:r="http://schemas.openxmlformats.org/officeDocument/2006/relationships" r:id="Rbe659bc822764c6a"/>
   </p:notesMasterIdLst>
   <p:sldIdLst>
-    <p:sldId xmlns:r="http://schemas.openxmlformats.org/officeDocument/2006/relationships" id="256" r:id="R2e68154f9d204ef9"/>
-    <p:sldId xmlns:r="http://schemas.openxmlformats.org/officeDocument/2006/relationships" id="257" r:id="Ra474c051823f4f99"/>
-    <p:sldId xmlns:r="http://schemas.openxmlformats.org/officeDocument/2006/relationships" id="258" r:id="R43de99c6fb7c4fcd"/>
-    <p:sldId xmlns:r="http://schemas.openxmlformats.org/officeDocument/2006/relationships" id="259" r:id="R91e120852f1e412a"/>
-    <p:sldId xmlns:r="http://schemas.openxmlformats.org/officeDocument/2006/relationships" id="260" r:id="Rdd86df233cf74537"/>
-    <p:sldId xmlns:r="http://schemas.openxmlformats.org/officeDocument/2006/relationships" id="261" r:id="Raf4deae29c7741f9"/>
-    <p:sldId xmlns:r="http://schemas.openxmlformats.org/officeDocument/2006/relationships" id="262" r:id="R3d5afad523984e4f"/>
-    <p:sldId xmlns:r="http://schemas.openxmlformats.org/officeDocument/2006/relationships" id="263" r:id="R4057e8737c0b4404"/>
-    <p:sldId xmlns:r="http://schemas.openxmlformats.org/officeDocument/2006/relationships" id="264" r:id="R7bfda2cb9d864c8f"/>
-    <p:sldId xmlns:r="http://schemas.openxmlformats.org/officeDocument/2006/relationships" id="265" r:id="R988a4e630d714065"/>
+    <p:sldId xmlns:r="http://schemas.openxmlformats.org/officeDocument/2006/relationships" id="256" r:id="Rf0af215a22d0461e"/>
+    <p:sldId xmlns:r="http://schemas.openxmlformats.org/officeDocument/2006/relationships" id="257" r:id="Rcef7f9cf0352450a"/>
+    <p:sldId xmlns:r="http://schemas.openxmlformats.org/officeDocument/2006/relationships" id="258" r:id="R5d307f9c9ae947b6"/>
+    <p:sldId xmlns:r="http://schemas.openxmlformats.org/officeDocument/2006/relationships" id="259" r:id="R162c8d130aac4a60"/>
+    <p:sldId xmlns:r="http://schemas.openxmlformats.org/officeDocument/2006/relationships" id="260" r:id="R5e6d70c2835948f9"/>
+    <p:sldId xmlns:r="http://schemas.openxmlformats.org/officeDocument/2006/relationships" id="261" r:id="R967477c5cb064841"/>
+    <p:sldId xmlns:r="http://schemas.openxmlformats.org/officeDocument/2006/relationships" id="262" r:id="R005a54fb7b014672"/>
+    <p:sldId xmlns:r="http://schemas.openxmlformats.org/officeDocument/2006/relationships" id="263" r:id="R9696a75b37684c31"/>
+    <p:sldId xmlns:r="http://schemas.openxmlformats.org/officeDocument/2006/relationships" id="264" r:id="R282720d2375940fb"/>
+    <p:sldId xmlns:r="http://schemas.openxmlformats.org/officeDocument/2006/relationships" id="265" r:id="R0c4e535a040c46f2"/>
   </p:sldIdLst>
   <p:sldSz cx="12192000" cy="6858000"/>
   <p:notesSz cx="6858000" cy="9144000"/>
@@ -451,7 +451,7 @@
           <a:lstStyle xmlns:a="http://schemas.openxmlformats.org/drawingml/2006/main"/>
           <a:p xmlns:a="http://schemas.openxmlformats.org/drawingml/2006/main">
             <a:r>
-              <a:t>BizHallu asks whether AI-generated business conclusions follow from the transaction evidence. I directed the project with AI-assisted implementation and review. My accounting and supply-management background motivates the distinction between a number that reconciles and a relationship that supports a decision. I will begin with a concrete ranking error, then discuss the evaluation and a proposed comparison.</a:t>
+              <a:t>I am a current MS student at Johns Hopkins Carey Business School, pursuing the Master of Science in Business Analytics and Artificial Intelligence. BizHallu asks whether AI-generated business conclusions follow from transaction evidence. I directed the project with AI-assisted implementation and review. My accounting and supply-management background motivates the distinction between a number that reconciles and a relationship that supports a decision.</a:t>
             </a:r>
           </a:p>
           <a:p xmlns:a="http://schemas.openxmlformats.org/drawingml/2006/main">
@@ -1449,7 +1449,7 @@
   </p:cSld>
   <p:clrMap bg1="lt1" tx1="dk1" bg2="lt2" tx2="dk2" accent1="accent1" accent2="accent2" accent3="accent3" accent4="accent4" accent5="accent5" accent6="accent6" hlink="hlink" folHlink="folHlink"/>
   <p:sldLayoutIdLst>
-    <p:sldLayoutId xmlns:r="http://schemas.openxmlformats.org/officeDocument/2006/relationships" id="2147483649" r:id="R0919d98eecfd4943"/>
+    <p:sldLayoutId xmlns:r="http://schemas.openxmlformats.org/officeDocument/2006/relationships" id="2147483649" r:id="Rc07193c8da044ff9"/>
   </p:sldLayoutIdLst>
   <p:txStyles>
     <p:titleStyle>
@@ -2296,7 +2296,7 @@
           <p:cNvPr id="6" name="">
             <a:extLst xmlns:a="http://schemas.openxmlformats.org/drawingml/2006/main">
               <a:ext uri="{FF2B5EF4-FFF2-40B4-BE49-F238E27FC236}">
-                <a16:creationId xmlns:a16="http://schemas.microsoft.com/office/drawing/2014/main" id="{A9B7E305-3ACE-4B79-B545-C0C1C44033F4}"/>
+                <a16:creationId xmlns:a16="http://schemas.microsoft.com/office/drawing/2014/main" id="{752EB0B0-9436-47F4-BB85-0DC153DA0728}"/>
               </a:ext>
             </a:extLst>
           </p:cNvPr>
@@ -2353,7 +2353,7 @@
           <p:cNvPr id="2" name="">
             <a:extLst xmlns:a="http://schemas.openxmlformats.org/drawingml/2006/main">
               <a:ext uri="{FF2B5EF4-FFF2-40B4-BE49-F238E27FC236}">
-                <a16:creationId xmlns:a16="http://schemas.microsoft.com/office/drawing/2014/main" id="{E60EAD77-6159-4AEE-9E07-2B32407A2ED6}"/>
+                <a16:creationId xmlns:a16="http://schemas.microsoft.com/office/drawing/2014/main" id="{DA2466E2-0E43-4BC4-8A16-D7CF1DB484D1}"/>
               </a:ext>
             </a:extLst>
           </p:cNvPr>
@@ -2410,7 +2410,7 @@
           <p:cNvPr id="3" name="">
             <a:extLst xmlns:a="http://schemas.openxmlformats.org/drawingml/2006/main">
               <a:ext uri="{FF2B5EF4-FFF2-40B4-BE49-F238E27FC236}">
-                <a16:creationId xmlns:a16="http://schemas.microsoft.com/office/drawing/2014/main" id="{022A5DC0-CD65-4555-94C1-630F2EBD2C0B}"/>
+                <a16:creationId xmlns:a16="http://schemas.microsoft.com/office/drawing/2014/main" id="{74FC6D29-EB26-4F61-9649-EB69C211CE2A}"/>
               </a:ext>
             </a:extLst>
           </p:cNvPr>
@@ -2457,7 +2457,7 @@
                 <a:ea typeface="Arial"/>
                 <a:cs typeface="Arial"/>
               </a:rPr>
-              <a:t>Yuchi Wang</a:t>
+              <a:t>Yuchi Wang, MS student in Business Analytics and AI</a:t>
             </a:r>
           </a:p>
           <a:p xmlns:a="http://schemas.openxmlformats.org/drawingml/2006/main">
@@ -2480,7 +2480,7 @@
                 <a:ea typeface="Arial"/>
                 <a:cs typeface="Arial"/>
               </a:rPr>
-              <a:t>Accounting and supply management</a:t>
+              <a:t>Johns Hopkins Carey Business School</a:t>
             </a:r>
           </a:p>
         </p:txBody>
@@ -2490,7 +2490,7 @@
           <p:cNvPr id="4" name="">
             <a:extLst xmlns:a="http://schemas.openxmlformats.org/drawingml/2006/main">
               <a:ext uri="{FF2B5EF4-FFF2-40B4-BE49-F238E27FC236}">
-                <a16:creationId xmlns:a16="http://schemas.microsoft.com/office/drawing/2014/main" id="{8FFBD413-C5AE-4222-8A2C-AF55F8E190E4}"/>
+                <a16:creationId xmlns:a16="http://schemas.microsoft.com/office/drawing/2014/main" id="{60478581-6BFB-4EDC-B877-EDB76706C8A7}"/>
               </a:ext>
             </a:extLst>
           </p:cNvPr>
@@ -2547,7 +2547,7 @@
           <p:cNvPr id="5" name="">
             <a:extLst xmlns:a="http://schemas.openxmlformats.org/drawingml/2006/main">
               <a:ext uri="{FF2B5EF4-FFF2-40B4-BE49-F238E27FC236}">
-                <a16:creationId xmlns:a16="http://schemas.microsoft.com/office/drawing/2014/main" id="{E7EA8EC9-127A-4E6E-8976-824A8BAE6D5D}"/>
+                <a16:creationId xmlns:a16="http://schemas.microsoft.com/office/drawing/2014/main" id="{66F1DCCE-8A1F-4AE2-BB5E-7CC9FF0A0D6C}"/>
               </a:ext>
             </a:extLst>
           </p:cNvPr>
@@ -2602,7 +2602,7 @@
     </p:spTree>
     <p:extLst>
       <p:ext uri="{BB962C8B-B14F-4D97-AF65-F5344CB8AC3E}">
-        <p14:creationId xmlns:p14="http://schemas.microsoft.com/office/powerpoint/2010/main" val="1379479509"/>
+        <p14:creationId xmlns:p14="http://schemas.microsoft.com/office/powerpoint/2010/main" val="586092470"/>
       </p:ext>
     </p:extLst>
   </p:cSld>
@@ -2633,7 +2633,7 @@
           <p:cNvPr id="7" name="">
             <a:extLst xmlns:a="http://schemas.openxmlformats.org/drawingml/2006/main">
               <a:ext uri="{FF2B5EF4-FFF2-40B4-BE49-F238E27FC236}">
-                <a16:creationId xmlns:a16="http://schemas.microsoft.com/office/drawing/2014/main" id="{6DB00F26-5857-4C70-96E7-76C76BC18A3B}"/>
+                <a16:creationId xmlns:a16="http://schemas.microsoft.com/office/drawing/2014/main" id="{977354D7-6D8F-4340-91F9-565A150124F7}"/>
               </a:ext>
             </a:extLst>
           </p:cNvPr>
@@ -2690,7 +2690,7 @@
           <p:cNvPr id="2" name="">
             <a:extLst xmlns:a="http://schemas.openxmlformats.org/drawingml/2006/main">
               <a:ext uri="{FF2B5EF4-FFF2-40B4-BE49-F238E27FC236}">
-                <a16:creationId xmlns:a16="http://schemas.microsoft.com/office/drawing/2014/main" id="{0AE29B8A-0CD4-4B1E-8A20-44A5C2023253}"/>
+                <a16:creationId xmlns:a16="http://schemas.microsoft.com/office/drawing/2014/main" id="{DF6C9FDE-B802-46E7-8B89-F8950988F386}"/>
               </a:ext>
             </a:extLst>
           </p:cNvPr>
@@ -2747,7 +2747,7 @@
           <p:cNvPr id="3" name="">
             <a:extLst xmlns:a="http://schemas.openxmlformats.org/drawingml/2006/main">
               <a:ext uri="{FF2B5EF4-FFF2-40B4-BE49-F238E27FC236}">
-                <a16:creationId xmlns:a16="http://schemas.microsoft.com/office/drawing/2014/main" id="{2FD4E23A-EE52-4F5A-8810-2F9D70234430}"/>
+                <a16:creationId xmlns:a16="http://schemas.microsoft.com/office/drawing/2014/main" id="{931A64B3-00EB-4944-857A-661BF7B27E36}"/>
               </a:ext>
             </a:extLst>
           </p:cNvPr>
@@ -2804,7 +2804,7 @@
           <p:cNvPr id="4" name="">
             <a:extLst xmlns:a="http://schemas.openxmlformats.org/drawingml/2006/main">
               <a:ext uri="{FF2B5EF4-FFF2-40B4-BE49-F238E27FC236}">
-                <a16:creationId xmlns:a16="http://schemas.microsoft.com/office/drawing/2014/main" id="{B084F3A6-9558-404B-8508-078B7A728FC7}"/>
+                <a16:creationId xmlns:a16="http://schemas.microsoft.com/office/drawing/2014/main" id="{342AF531-7B7E-41E1-95FF-B512C5968FF5}"/>
               </a:ext>
             </a:extLst>
           </p:cNvPr>
@@ -2861,7 +2861,7 @@
           <p:cNvPr id="5" name="">
             <a:extLst xmlns:a="http://schemas.openxmlformats.org/drawingml/2006/main">
               <a:ext uri="{FF2B5EF4-FFF2-40B4-BE49-F238E27FC236}">
-                <a16:creationId xmlns:a16="http://schemas.microsoft.com/office/drawing/2014/main" id="{748FBBC5-E174-4224-9C06-D092D55D52E0}"/>
+                <a16:creationId xmlns:a16="http://schemas.microsoft.com/office/drawing/2014/main" id="{7B6D23DB-3CF0-4107-A610-1C613B0F9670}"/>
               </a:ext>
             </a:extLst>
           </p:cNvPr>
@@ -2918,7 +2918,7 @@
           <p:cNvPr id="6" name="">
             <a:extLst xmlns:a="http://schemas.openxmlformats.org/drawingml/2006/main">
               <a:ext uri="{FF2B5EF4-FFF2-40B4-BE49-F238E27FC236}">
-                <a16:creationId xmlns:a16="http://schemas.microsoft.com/office/drawing/2014/main" id="{3CF75F88-37F6-4851-B4E7-E9801A43DF96}"/>
+                <a16:creationId xmlns:a16="http://schemas.microsoft.com/office/drawing/2014/main" id="{36325060-D455-42EE-B311-4A90B3D289E2}"/>
               </a:ext>
             </a:extLst>
           </p:cNvPr>
@@ -2973,7 +2973,7 @@
     </p:spTree>
     <p:extLst>
       <p:ext uri="{BB962C8B-B14F-4D97-AF65-F5344CB8AC3E}">
-        <p14:creationId xmlns:p14="http://schemas.microsoft.com/office/powerpoint/2010/main" val="1342960785"/>
+        <p14:creationId xmlns:p14="http://schemas.microsoft.com/office/powerpoint/2010/main" val="2037535984"/>
       </p:ext>
     </p:extLst>
   </p:cSld>
@@ -3004,7 +3004,7 @@
           <p:cNvPr id="6" name="">
             <a:extLst xmlns:a="http://schemas.openxmlformats.org/drawingml/2006/main">
               <a:ext uri="{FF2B5EF4-FFF2-40B4-BE49-F238E27FC236}">
-                <a16:creationId xmlns:a16="http://schemas.microsoft.com/office/drawing/2014/main" id="{7B7B15A3-88EA-4BA9-AFA4-32DE474A259B}"/>
+                <a16:creationId xmlns:a16="http://schemas.microsoft.com/office/drawing/2014/main" id="{87B4C276-4B43-479B-8748-133E39F29DC5}"/>
               </a:ext>
             </a:extLst>
           </p:cNvPr>
@@ -3061,7 +3061,7 @@
           <p:cNvPr id="2" name="">
             <a:extLst xmlns:a="http://schemas.openxmlformats.org/drawingml/2006/main">
               <a:ext uri="{FF2B5EF4-FFF2-40B4-BE49-F238E27FC236}">
-                <a16:creationId xmlns:a16="http://schemas.microsoft.com/office/drawing/2014/main" id="{B39CF087-4F3E-41C7-8DEF-162D723591DD}"/>
+                <a16:creationId xmlns:a16="http://schemas.microsoft.com/office/drawing/2014/main" id="{1402A2A3-D372-47F1-AFAC-49436DE22A5B}"/>
               </a:ext>
             </a:extLst>
           </p:cNvPr>
@@ -3861,7 +3861,7 @@
           <p:cNvPr id="4" name="">
             <a:extLst xmlns:a="http://schemas.openxmlformats.org/drawingml/2006/main">
               <a:ext uri="{FF2B5EF4-FFF2-40B4-BE49-F238E27FC236}">
-                <a16:creationId xmlns:a16="http://schemas.microsoft.com/office/drawing/2014/main" id="{07DD3883-B1CA-4BD8-AFA4-8EF3B329CE56}"/>
+                <a16:creationId xmlns:a16="http://schemas.microsoft.com/office/drawing/2014/main" id="{2F5D62C9-123B-4086-97E0-3D467D3C7783}"/>
               </a:ext>
             </a:extLst>
           </p:cNvPr>
@@ -3941,7 +3941,7 @@
           <p:cNvPr id="5" name="">
             <a:extLst xmlns:a="http://schemas.openxmlformats.org/drawingml/2006/main">
               <a:ext uri="{FF2B5EF4-FFF2-40B4-BE49-F238E27FC236}">
-                <a16:creationId xmlns:a16="http://schemas.microsoft.com/office/drawing/2014/main" id="{A18D4B10-769C-4AA1-A450-264E113AF2F2}"/>
+                <a16:creationId xmlns:a16="http://schemas.microsoft.com/office/drawing/2014/main" id="{E01634E4-A85C-4DB7-9C70-4908CF316F1D}"/>
               </a:ext>
             </a:extLst>
           </p:cNvPr>
@@ -3996,7 +3996,7 @@
     </p:spTree>
     <p:extLst>
       <p:ext uri="{BB962C8B-B14F-4D97-AF65-F5344CB8AC3E}">
-        <p14:creationId xmlns:p14="http://schemas.microsoft.com/office/powerpoint/2010/main" val="389260341"/>
+        <p14:creationId xmlns:p14="http://schemas.microsoft.com/office/powerpoint/2010/main" val="1476271976"/>
       </p:ext>
     </p:extLst>
   </p:cSld>
@@ -4027,7 +4027,7 @@
           <p:cNvPr id="6" name="">
             <a:extLst xmlns:a="http://schemas.openxmlformats.org/drawingml/2006/main">
               <a:ext uri="{FF2B5EF4-FFF2-40B4-BE49-F238E27FC236}">
-                <a16:creationId xmlns:a16="http://schemas.microsoft.com/office/drawing/2014/main" id="{9D43983B-A543-48CA-8230-36AAB9DAF542}"/>
+                <a16:creationId xmlns:a16="http://schemas.microsoft.com/office/drawing/2014/main" id="{54A94091-9868-4785-AEDD-14A97F2541B2}"/>
               </a:ext>
             </a:extLst>
           </p:cNvPr>
@@ -4084,7 +4084,7 @@
           <p:cNvPr id="2" name="">
             <a:extLst xmlns:a="http://schemas.openxmlformats.org/drawingml/2006/main">
               <a:ext uri="{FF2B5EF4-FFF2-40B4-BE49-F238E27FC236}">
-                <a16:creationId xmlns:a16="http://schemas.microsoft.com/office/drawing/2014/main" id="{D4947BF6-B7B2-48CD-83DF-4CA982479434}"/>
+                <a16:creationId xmlns:a16="http://schemas.microsoft.com/office/drawing/2014/main" id="{F9728EC5-63CC-4155-AD94-5B5EC3EB05F2}"/>
               </a:ext>
             </a:extLst>
           </p:cNvPr>
@@ -4589,7 +4589,7 @@
           <p:cNvPr id="4" name="">
             <a:extLst xmlns:a="http://schemas.openxmlformats.org/drawingml/2006/main">
               <a:ext uri="{FF2B5EF4-FFF2-40B4-BE49-F238E27FC236}">
-                <a16:creationId xmlns:a16="http://schemas.microsoft.com/office/drawing/2014/main" id="{BA1234DE-24B1-4831-9544-3A84ADBFB68F}"/>
+                <a16:creationId xmlns:a16="http://schemas.microsoft.com/office/drawing/2014/main" id="{89EA186F-DD9F-48C9-AAB4-BC21821B8764}"/>
               </a:ext>
             </a:extLst>
           </p:cNvPr>
@@ -4646,7 +4646,7 @@
           <p:cNvPr id="5" name="">
             <a:extLst xmlns:a="http://schemas.openxmlformats.org/drawingml/2006/main">
               <a:ext uri="{FF2B5EF4-FFF2-40B4-BE49-F238E27FC236}">
-                <a16:creationId xmlns:a16="http://schemas.microsoft.com/office/drawing/2014/main" id="{B4F0B936-C545-4049-8C57-7D687AA98CB1}"/>
+                <a16:creationId xmlns:a16="http://schemas.microsoft.com/office/drawing/2014/main" id="{577CB603-919E-4C66-BB5F-391E9D41A253}"/>
               </a:ext>
             </a:extLst>
           </p:cNvPr>
@@ -4701,7 +4701,7 @@
     </p:spTree>
     <p:extLst>
       <p:ext uri="{BB962C8B-B14F-4D97-AF65-F5344CB8AC3E}">
-        <p14:creationId xmlns:p14="http://schemas.microsoft.com/office/powerpoint/2010/main" val="835417833"/>
+        <p14:creationId xmlns:p14="http://schemas.microsoft.com/office/powerpoint/2010/main" val="1929598731"/>
       </p:ext>
     </p:extLst>
   </p:cSld>
@@ -4732,7 +4732,7 @@
           <p:cNvPr id="6" name="">
             <a:extLst xmlns:a="http://schemas.openxmlformats.org/drawingml/2006/main">
               <a:ext uri="{FF2B5EF4-FFF2-40B4-BE49-F238E27FC236}">
-                <a16:creationId xmlns:a16="http://schemas.microsoft.com/office/drawing/2014/main" id="{6DC26EE6-3F68-477E-90BC-FFEF748BED20}"/>
+                <a16:creationId xmlns:a16="http://schemas.microsoft.com/office/drawing/2014/main" id="{C66948EB-91B3-4B7B-B512-0B9794BE8A3C}"/>
               </a:ext>
             </a:extLst>
           </p:cNvPr>
@@ -4789,7 +4789,7 @@
           <p:cNvPr id="2" name="">
             <a:extLst xmlns:a="http://schemas.openxmlformats.org/drawingml/2006/main">
               <a:ext uri="{FF2B5EF4-FFF2-40B4-BE49-F238E27FC236}">
-                <a16:creationId xmlns:a16="http://schemas.microsoft.com/office/drawing/2014/main" id="{596E9FAB-67D9-4D3A-B41B-9E38C372CD81}"/>
+                <a16:creationId xmlns:a16="http://schemas.microsoft.com/office/drawing/2014/main" id="{361B50EC-9FD5-4C12-9F7F-E1728D37CFDE}"/>
               </a:ext>
             </a:extLst>
           </p:cNvPr>
@@ -4846,7 +4846,7 @@
           <p:cNvPr id="3" name="">
             <a:extLst xmlns:a="http://schemas.openxmlformats.org/drawingml/2006/main">
               <a:ext uri="{FF2B5EF4-FFF2-40B4-BE49-F238E27FC236}">
-                <a16:creationId xmlns:a16="http://schemas.microsoft.com/office/drawing/2014/main" id="{45F6870F-BE9F-4683-8D4C-F236070BFD99}"/>
+                <a16:creationId xmlns:a16="http://schemas.microsoft.com/office/drawing/2014/main" id="{22FFD6B2-F8AF-4C9B-A790-21F2370212C6}"/>
               </a:ext>
             </a:extLst>
           </p:cNvPr>
@@ -4903,7 +4903,7 @@
           <p:cNvPr id="4" name="">
             <a:extLst xmlns:a="http://schemas.openxmlformats.org/drawingml/2006/main">
               <a:ext uri="{FF2B5EF4-FFF2-40B4-BE49-F238E27FC236}">
-                <a16:creationId xmlns:a16="http://schemas.microsoft.com/office/drawing/2014/main" id="{B4681465-2292-49A1-876B-41B6D150C596}"/>
+                <a16:creationId xmlns:a16="http://schemas.microsoft.com/office/drawing/2014/main" id="{7A1E5556-A396-48A4-A8BA-7B2A6A679B2B}"/>
               </a:ext>
             </a:extLst>
           </p:cNvPr>
@@ -4960,7 +4960,7 @@
           <p:cNvPr id="5" name="">
             <a:extLst xmlns:a="http://schemas.openxmlformats.org/drawingml/2006/main">
               <a:ext uri="{FF2B5EF4-FFF2-40B4-BE49-F238E27FC236}">
-                <a16:creationId xmlns:a16="http://schemas.microsoft.com/office/drawing/2014/main" id="{6A9A8A17-8D7C-4499-B356-CECA308D6221}"/>
+                <a16:creationId xmlns:a16="http://schemas.microsoft.com/office/drawing/2014/main" id="{F7A7F2FE-7DBB-4ECC-BC9C-8FD0F7FE58C2}"/>
               </a:ext>
             </a:extLst>
           </p:cNvPr>
@@ -5015,7 +5015,7 @@
     </p:spTree>
     <p:extLst>
       <p:ext uri="{BB962C8B-B14F-4D97-AF65-F5344CB8AC3E}">
-        <p14:creationId xmlns:p14="http://schemas.microsoft.com/office/powerpoint/2010/main" val="700233246"/>
+        <p14:creationId xmlns:p14="http://schemas.microsoft.com/office/powerpoint/2010/main" val="559700234"/>
       </p:ext>
     </p:extLst>
   </p:cSld>
@@ -5046,7 +5046,7 @@
           <p:cNvPr id="7" name="">
             <a:extLst xmlns:a="http://schemas.openxmlformats.org/drawingml/2006/main">
               <a:ext uri="{FF2B5EF4-FFF2-40B4-BE49-F238E27FC236}">
-                <a16:creationId xmlns:a16="http://schemas.microsoft.com/office/drawing/2014/main" id="{D0269070-BA22-4EF3-B790-51AD0F652355}"/>
+                <a16:creationId xmlns:a16="http://schemas.microsoft.com/office/drawing/2014/main" id="{4F34CFEF-ACA2-4656-88A3-15F0F2E91194}"/>
               </a:ext>
             </a:extLst>
           </p:cNvPr>
@@ -5103,7 +5103,7 @@
           <p:cNvPr id="2" name="">
             <a:extLst xmlns:a="http://schemas.openxmlformats.org/drawingml/2006/main">
               <a:ext uri="{FF2B5EF4-FFF2-40B4-BE49-F238E27FC236}">
-                <a16:creationId xmlns:a16="http://schemas.microsoft.com/office/drawing/2014/main" id="{95EE1F80-5040-4FFD-B939-C5F0287F91C1}"/>
+                <a16:creationId xmlns:a16="http://schemas.microsoft.com/office/drawing/2014/main" id="{B1BF2071-890D-4416-9B24-51D91E69A84E}"/>
               </a:ext>
             </a:extLst>
           </p:cNvPr>
@@ -5160,7 +5160,7 @@
           <p:cNvPr id="3" name="">
             <a:extLst xmlns:a="http://schemas.openxmlformats.org/drawingml/2006/main">
               <a:ext uri="{FF2B5EF4-FFF2-40B4-BE49-F238E27FC236}">
-                <a16:creationId xmlns:a16="http://schemas.microsoft.com/office/drawing/2014/main" id="{7682EE87-C75D-4FDF-ADA5-996D2291C655}"/>
+                <a16:creationId xmlns:a16="http://schemas.microsoft.com/office/drawing/2014/main" id="{CB235008-C2B4-4B64-AC7B-14D3DD74F439}"/>
               </a:ext>
             </a:extLst>
           </p:cNvPr>
@@ -5217,7 +5217,7 @@
           <p:cNvPr id="4" name="">
             <a:extLst xmlns:a="http://schemas.openxmlformats.org/drawingml/2006/main">
               <a:ext uri="{FF2B5EF4-FFF2-40B4-BE49-F238E27FC236}">
-                <a16:creationId xmlns:a16="http://schemas.microsoft.com/office/drawing/2014/main" id="{E2A08B0F-5608-46DA-A414-25765094BF0D}"/>
+                <a16:creationId xmlns:a16="http://schemas.microsoft.com/office/drawing/2014/main" id="{29D94D72-9295-408B-82C4-0A428E6A0F4A}"/>
               </a:ext>
             </a:extLst>
           </p:cNvPr>
@@ -5274,7 +5274,7 @@
           <p:cNvPr id="5" name="">
             <a:extLst xmlns:a="http://schemas.openxmlformats.org/drawingml/2006/main">
               <a:ext uri="{FF2B5EF4-FFF2-40B4-BE49-F238E27FC236}">
-                <a16:creationId xmlns:a16="http://schemas.microsoft.com/office/drawing/2014/main" id="{C9768560-A3A2-4735-B1F0-ABA3E011167D}"/>
+                <a16:creationId xmlns:a16="http://schemas.microsoft.com/office/drawing/2014/main" id="{7446E298-5277-4780-9501-7A0C48D79125}"/>
               </a:ext>
             </a:extLst>
           </p:cNvPr>
@@ -5331,7 +5331,7 @@
           <p:cNvPr id="6" name="">
             <a:extLst xmlns:a="http://schemas.openxmlformats.org/drawingml/2006/main">
               <a:ext uri="{FF2B5EF4-FFF2-40B4-BE49-F238E27FC236}">
-                <a16:creationId xmlns:a16="http://schemas.microsoft.com/office/drawing/2014/main" id="{645C666E-5738-4CF3-9627-F8E0B5161AF0}"/>
+                <a16:creationId xmlns:a16="http://schemas.microsoft.com/office/drawing/2014/main" id="{D6785104-2797-417A-8299-355DFFF49563}"/>
               </a:ext>
             </a:extLst>
           </p:cNvPr>
@@ -5386,7 +5386,7 @@
     </p:spTree>
     <p:extLst>
       <p:ext uri="{BB962C8B-B14F-4D97-AF65-F5344CB8AC3E}">
-        <p14:creationId xmlns:p14="http://schemas.microsoft.com/office/powerpoint/2010/main" val="1454293917"/>
+        <p14:creationId xmlns:p14="http://schemas.microsoft.com/office/powerpoint/2010/main" val="1736915562"/>
       </p:ext>
     </p:extLst>
   </p:cSld>
@@ -5417,7 +5417,7 @@
           <p:cNvPr id="10" name="">
             <a:extLst xmlns:a="http://schemas.openxmlformats.org/drawingml/2006/main">
               <a:ext uri="{FF2B5EF4-FFF2-40B4-BE49-F238E27FC236}">
-                <a16:creationId xmlns:a16="http://schemas.microsoft.com/office/drawing/2014/main" id="{BD493E17-3424-49C7-9E1C-F5FA46A3433B}"/>
+                <a16:creationId xmlns:a16="http://schemas.microsoft.com/office/drawing/2014/main" id="{446B1864-4F20-452B-BB89-7C931B3C74C0}"/>
               </a:ext>
             </a:extLst>
           </p:cNvPr>
@@ -5481,7 +5481,7 @@
         </p:xfrm>
         <a:graphic xmlns:a="http://schemas.openxmlformats.org/drawingml/2006/main">
           <a:graphicData uri="http://schemas.openxmlformats.org/drawingml/2006/chart">
-            <c:chart xmlns:r="http://schemas.openxmlformats.org/officeDocument/2006/relationships" xmlns:c="http://schemas.openxmlformats.org/drawingml/2006/chart" r:id="Rebce53c98eba4d87"/>
+            <c:chart xmlns:r="http://schemas.openxmlformats.org/officeDocument/2006/relationships" xmlns:c="http://schemas.openxmlformats.org/drawingml/2006/chart" r:id="Rfcdceb560ca14532"/>
           </a:graphicData>
         </a:graphic>
       </p:graphicFrame>
@@ -5490,7 +5490,7 @@
           <p:cNvPr id="3" name="">
             <a:extLst xmlns:a="http://schemas.openxmlformats.org/drawingml/2006/main">
               <a:ext uri="{FF2B5EF4-FFF2-40B4-BE49-F238E27FC236}">
-                <a16:creationId xmlns:a16="http://schemas.microsoft.com/office/drawing/2014/main" id="{680C0CDE-DA0D-4FBB-A19F-27B8841CC62E}"/>
+                <a16:creationId xmlns:a16="http://schemas.microsoft.com/office/drawing/2014/main" id="{AF15F41C-48F3-4589-A637-EAD0FC0C9557}"/>
               </a:ext>
             </a:extLst>
           </p:cNvPr>
@@ -5547,7 +5547,7 @@
           <p:cNvPr id="4" name="">
             <a:extLst xmlns:a="http://schemas.openxmlformats.org/drawingml/2006/main">
               <a:ext uri="{FF2B5EF4-FFF2-40B4-BE49-F238E27FC236}">
-                <a16:creationId xmlns:a16="http://schemas.microsoft.com/office/drawing/2014/main" id="{2F996A39-AC46-4D00-B53D-1C6BD3EACAC6}"/>
+                <a16:creationId xmlns:a16="http://schemas.microsoft.com/office/drawing/2014/main" id="{8E7C53D8-02C8-4620-ABCF-C2332BEC2AAB}"/>
               </a:ext>
             </a:extLst>
           </p:cNvPr>
@@ -5604,7 +5604,7 @@
           <p:cNvPr id="5" name="">
             <a:extLst xmlns:a="http://schemas.openxmlformats.org/drawingml/2006/main">
               <a:ext uri="{FF2B5EF4-FFF2-40B4-BE49-F238E27FC236}">
-                <a16:creationId xmlns:a16="http://schemas.microsoft.com/office/drawing/2014/main" id="{6DE215C1-A364-43A2-B2FD-B6733CF097F4}"/>
+                <a16:creationId xmlns:a16="http://schemas.microsoft.com/office/drawing/2014/main" id="{B7088E22-980A-4E90-9D82-072DB81F06D4}"/>
               </a:ext>
             </a:extLst>
           </p:cNvPr>
@@ -5707,7 +5707,7 @@
           <p:cNvPr id="6" name="">
             <a:extLst xmlns:a="http://schemas.openxmlformats.org/drawingml/2006/main">
               <a:ext uri="{FF2B5EF4-FFF2-40B4-BE49-F238E27FC236}">
-                <a16:creationId xmlns:a16="http://schemas.microsoft.com/office/drawing/2014/main" id="{5A3AE44E-BCF7-4A4B-BB30-3137B2D2771C}"/>
+                <a16:creationId xmlns:a16="http://schemas.microsoft.com/office/drawing/2014/main" id="{E76CB1E6-E23D-44E2-9E9F-8EBDAAF8AB82}"/>
               </a:ext>
             </a:extLst>
           </p:cNvPr>
@@ -5764,7 +5764,7 @@
           <p:cNvPr id="7" name="">
             <a:extLst xmlns:a="http://schemas.openxmlformats.org/drawingml/2006/main">
               <a:ext uri="{FF2B5EF4-FFF2-40B4-BE49-F238E27FC236}">
-                <a16:creationId xmlns:a16="http://schemas.microsoft.com/office/drawing/2014/main" id="{C8437045-365E-4CC7-AFD8-2D9F500D396E}"/>
+                <a16:creationId xmlns:a16="http://schemas.microsoft.com/office/drawing/2014/main" id="{BF84DC5F-52DB-4391-94B8-CF8F0D115F02}"/>
               </a:ext>
             </a:extLst>
           </p:cNvPr>
@@ -5821,7 +5821,7 @@
           <p:cNvPr id="8" name="">
             <a:extLst xmlns:a="http://schemas.openxmlformats.org/drawingml/2006/main">
               <a:ext uri="{FF2B5EF4-FFF2-40B4-BE49-F238E27FC236}">
-                <a16:creationId xmlns:a16="http://schemas.microsoft.com/office/drawing/2014/main" id="{594ACDD8-ADB3-4A51-A224-A8A4A459A85F}"/>
+                <a16:creationId xmlns:a16="http://schemas.microsoft.com/office/drawing/2014/main" id="{EDEB5A0C-7B81-4F16-8884-E239D8DE0ABC}"/>
               </a:ext>
             </a:extLst>
           </p:cNvPr>
@@ -5878,7 +5878,7 @@
           <p:cNvPr id="9" name="">
             <a:extLst xmlns:a="http://schemas.openxmlformats.org/drawingml/2006/main">
               <a:ext uri="{FF2B5EF4-FFF2-40B4-BE49-F238E27FC236}">
-                <a16:creationId xmlns:a16="http://schemas.microsoft.com/office/drawing/2014/main" id="{69CAEF70-3694-42C8-AD0D-7CE16F63E891}"/>
+                <a16:creationId xmlns:a16="http://schemas.microsoft.com/office/drawing/2014/main" id="{FD55691D-3B47-4C34-A8FA-6F4A4154516F}"/>
               </a:ext>
             </a:extLst>
           </p:cNvPr>
@@ -5933,7 +5933,7 @@
     </p:spTree>
     <p:extLst>
       <p:ext uri="{BB962C8B-B14F-4D97-AF65-F5344CB8AC3E}">
-        <p14:creationId xmlns:p14="http://schemas.microsoft.com/office/powerpoint/2010/main" val="1261481319"/>
+        <p14:creationId xmlns:p14="http://schemas.microsoft.com/office/powerpoint/2010/main" val="1596619827"/>
       </p:ext>
     </p:extLst>
   </p:cSld>
@@ -5964,7 +5964,7 @@
           <p:cNvPr id="7" name="">
             <a:extLst xmlns:a="http://schemas.openxmlformats.org/drawingml/2006/main">
               <a:ext uri="{FF2B5EF4-FFF2-40B4-BE49-F238E27FC236}">
-                <a16:creationId xmlns:a16="http://schemas.microsoft.com/office/drawing/2014/main" id="{9DA96254-C45B-4674-8781-EE71305D6279}"/>
+                <a16:creationId xmlns:a16="http://schemas.microsoft.com/office/drawing/2014/main" id="{224B605A-74F4-43AF-80FD-EB143DA8DFC6}"/>
               </a:ext>
             </a:extLst>
           </p:cNvPr>
@@ -6021,7 +6021,7 @@
           <p:cNvPr id="2" name="">
             <a:extLst xmlns:a="http://schemas.openxmlformats.org/drawingml/2006/main">
               <a:ext uri="{FF2B5EF4-FFF2-40B4-BE49-F238E27FC236}">
-                <a16:creationId xmlns:a16="http://schemas.microsoft.com/office/drawing/2014/main" id="{37F9633D-3287-4F71-AF7E-615CA03E6398}"/>
+                <a16:creationId xmlns:a16="http://schemas.microsoft.com/office/drawing/2014/main" id="{621194D5-1D53-4E7C-A72D-DF3A5B38E00D}"/>
               </a:ext>
             </a:extLst>
           </p:cNvPr>
@@ -6078,7 +6078,7 @@
           <p:cNvPr id="3" name="">
             <a:extLst xmlns:a="http://schemas.openxmlformats.org/drawingml/2006/main">
               <a:ext uri="{FF2B5EF4-FFF2-40B4-BE49-F238E27FC236}">
-                <a16:creationId xmlns:a16="http://schemas.microsoft.com/office/drawing/2014/main" id="{E7C14655-8329-4640-B405-862378296C8C}"/>
+                <a16:creationId xmlns:a16="http://schemas.microsoft.com/office/drawing/2014/main" id="{4CAFE508-7D66-41E1-AF4C-79D91C9FA9E6}"/>
               </a:ext>
             </a:extLst>
           </p:cNvPr>
@@ -6135,7 +6135,7 @@
           <p:cNvPr id="4" name="">
             <a:extLst xmlns:a="http://schemas.openxmlformats.org/drawingml/2006/main">
               <a:ext uri="{FF2B5EF4-FFF2-40B4-BE49-F238E27FC236}">
-                <a16:creationId xmlns:a16="http://schemas.microsoft.com/office/drawing/2014/main" id="{DE53D9C6-CFCF-47F5-A874-1843DE5BAD37}"/>
+                <a16:creationId xmlns:a16="http://schemas.microsoft.com/office/drawing/2014/main" id="{08A9EFC0-F07E-443A-8DE8-AC955D590D02}"/>
               </a:ext>
             </a:extLst>
           </p:cNvPr>
@@ -6192,7 +6192,7 @@
           <p:cNvPr id="5" name="">
             <a:extLst xmlns:a="http://schemas.openxmlformats.org/drawingml/2006/main">
               <a:ext uri="{FF2B5EF4-FFF2-40B4-BE49-F238E27FC236}">
-                <a16:creationId xmlns:a16="http://schemas.microsoft.com/office/drawing/2014/main" id="{789C19C4-1C54-4062-98C4-9BD097AE3506}"/>
+                <a16:creationId xmlns:a16="http://schemas.microsoft.com/office/drawing/2014/main" id="{599961C1-1B27-4D74-A442-2C24E5E4C504}"/>
               </a:ext>
             </a:extLst>
           </p:cNvPr>
@@ -6249,7 +6249,7 @@
           <p:cNvPr id="6" name="">
             <a:extLst xmlns:a="http://schemas.openxmlformats.org/drawingml/2006/main">
               <a:ext uri="{FF2B5EF4-FFF2-40B4-BE49-F238E27FC236}">
-                <a16:creationId xmlns:a16="http://schemas.microsoft.com/office/drawing/2014/main" id="{2428187F-35B3-4CB0-826F-03E8B8DD090C}"/>
+                <a16:creationId xmlns:a16="http://schemas.microsoft.com/office/drawing/2014/main" id="{44C61617-561D-4B30-8C38-2DADE5EC48FE}"/>
               </a:ext>
             </a:extLst>
           </p:cNvPr>
@@ -6304,7 +6304,7 @@
     </p:spTree>
     <p:extLst>
       <p:ext uri="{BB962C8B-B14F-4D97-AF65-F5344CB8AC3E}">
-        <p14:creationId xmlns:p14="http://schemas.microsoft.com/office/powerpoint/2010/main" val="1208154026"/>
+        <p14:creationId xmlns:p14="http://schemas.microsoft.com/office/powerpoint/2010/main" val="1737642685"/>
       </p:ext>
     </p:extLst>
   </p:cSld>
@@ -6335,7 +6335,7 @@
           <p:cNvPr id="6" name="">
             <a:extLst xmlns:a="http://schemas.openxmlformats.org/drawingml/2006/main">
               <a:ext uri="{FF2B5EF4-FFF2-40B4-BE49-F238E27FC236}">
-                <a16:creationId xmlns:a16="http://schemas.microsoft.com/office/drawing/2014/main" id="{88E0481C-A1C5-4EFA-8D63-B783FB083BCC}"/>
+                <a16:creationId xmlns:a16="http://schemas.microsoft.com/office/drawing/2014/main" id="{80B3C823-5B2C-4D91-9A21-659644241C69}"/>
               </a:ext>
             </a:extLst>
           </p:cNvPr>
@@ -6392,7 +6392,7 @@
           <p:cNvPr id="2" name="">
             <a:extLst xmlns:a="http://schemas.openxmlformats.org/drawingml/2006/main">
               <a:ext uri="{FF2B5EF4-FFF2-40B4-BE49-F238E27FC236}">
-                <a16:creationId xmlns:a16="http://schemas.microsoft.com/office/drawing/2014/main" id="{3079390D-B60B-48A0-96A6-E7C4B663E53C}"/>
+                <a16:creationId xmlns:a16="http://schemas.microsoft.com/office/drawing/2014/main" id="{0B3AF89A-4C12-468F-9F76-57FE61342336}"/>
               </a:ext>
             </a:extLst>
           </p:cNvPr>
@@ -6449,7 +6449,7 @@
           <p:cNvPr id="3" name="">
             <a:extLst xmlns:a="http://schemas.openxmlformats.org/drawingml/2006/main">
               <a:ext uri="{FF2B5EF4-FFF2-40B4-BE49-F238E27FC236}">
-                <a16:creationId xmlns:a16="http://schemas.microsoft.com/office/drawing/2014/main" id="{8C6BC8D8-14A1-424A-B37A-2A7E47733752}"/>
+                <a16:creationId xmlns:a16="http://schemas.microsoft.com/office/drawing/2014/main" id="{E9F23A4B-E86C-4699-9773-38DFCD8B37DE}"/>
               </a:ext>
             </a:extLst>
           </p:cNvPr>
@@ -6506,7 +6506,7 @@
           <p:cNvPr id="4" name="">
             <a:extLst xmlns:a="http://schemas.openxmlformats.org/drawingml/2006/main">
               <a:ext uri="{FF2B5EF4-FFF2-40B4-BE49-F238E27FC236}">
-                <a16:creationId xmlns:a16="http://schemas.microsoft.com/office/drawing/2014/main" id="{275C3645-79C0-4BC3-A023-2A835DA38D49}"/>
+                <a16:creationId xmlns:a16="http://schemas.microsoft.com/office/drawing/2014/main" id="{6E2A201D-AB56-47C8-A873-407FF613A2DE}"/>
               </a:ext>
             </a:extLst>
           </p:cNvPr>
@@ -6563,7 +6563,7 @@
           <p:cNvPr id="5" name="">
             <a:extLst xmlns:a="http://schemas.openxmlformats.org/drawingml/2006/main">
               <a:ext uri="{FF2B5EF4-FFF2-40B4-BE49-F238E27FC236}">
-                <a16:creationId xmlns:a16="http://schemas.microsoft.com/office/drawing/2014/main" id="{BA6DE9B3-E5C6-4571-BD5B-1DFD784357A8}"/>
+                <a16:creationId xmlns:a16="http://schemas.microsoft.com/office/drawing/2014/main" id="{C167F590-5345-4249-9322-DEE53034E13C}"/>
               </a:ext>
             </a:extLst>
           </p:cNvPr>
@@ -6618,7 +6618,7 @@
     </p:spTree>
     <p:extLst>
       <p:ext uri="{BB962C8B-B14F-4D97-AF65-F5344CB8AC3E}">
-        <p14:creationId xmlns:p14="http://schemas.microsoft.com/office/powerpoint/2010/main" val="771196765"/>
+        <p14:creationId xmlns:p14="http://schemas.microsoft.com/office/powerpoint/2010/main" val="995171847"/>
       </p:ext>
     </p:extLst>
   </p:cSld>
@@ -6649,7 +6649,7 @@
           <p:cNvPr id="7" name="">
             <a:extLst xmlns:a="http://schemas.openxmlformats.org/drawingml/2006/main">
               <a:ext uri="{FF2B5EF4-FFF2-40B4-BE49-F238E27FC236}">
-                <a16:creationId xmlns:a16="http://schemas.microsoft.com/office/drawing/2014/main" id="{554EE766-B7B2-4563-87B4-B2CCFA3B8358}"/>
+                <a16:creationId xmlns:a16="http://schemas.microsoft.com/office/drawing/2014/main" id="{FB7296D9-DF9F-4864-935A-D7DFD0CCE8C5}"/>
               </a:ext>
             </a:extLst>
           </p:cNvPr>
@@ -6706,7 +6706,7 @@
           <p:cNvPr id="2" name="">
             <a:extLst xmlns:a="http://schemas.openxmlformats.org/drawingml/2006/main">
               <a:ext uri="{FF2B5EF4-FFF2-40B4-BE49-F238E27FC236}">
-                <a16:creationId xmlns:a16="http://schemas.microsoft.com/office/drawing/2014/main" id="{0F73CB70-ADD9-45FC-9AE1-9C8ED958C6C9}"/>
+                <a16:creationId xmlns:a16="http://schemas.microsoft.com/office/drawing/2014/main" id="{E7BC048A-C249-4B4B-AFA0-B8330E921C1F}"/>
               </a:ext>
             </a:extLst>
           </p:cNvPr>
@@ -6763,7 +6763,7 @@
           <p:cNvPr id="3" name="">
             <a:extLst xmlns:a="http://schemas.openxmlformats.org/drawingml/2006/main">
               <a:ext uri="{FF2B5EF4-FFF2-40B4-BE49-F238E27FC236}">
-                <a16:creationId xmlns:a16="http://schemas.microsoft.com/office/drawing/2014/main" id="{7FA09D24-CCAB-4161-A677-C7D105828F38}"/>
+                <a16:creationId xmlns:a16="http://schemas.microsoft.com/office/drawing/2014/main" id="{82E156F2-5AA9-45D5-B099-0458AB0B8DEB}"/>
               </a:ext>
             </a:extLst>
           </p:cNvPr>
@@ -6820,7 +6820,7 @@
           <p:cNvPr id="4" name="">
             <a:extLst xmlns:a="http://schemas.openxmlformats.org/drawingml/2006/main">
               <a:ext uri="{FF2B5EF4-FFF2-40B4-BE49-F238E27FC236}">
-                <a16:creationId xmlns:a16="http://schemas.microsoft.com/office/drawing/2014/main" id="{7550AC89-F6F5-4BB1-9EBF-7BE4154A26B6}"/>
+                <a16:creationId xmlns:a16="http://schemas.microsoft.com/office/drawing/2014/main" id="{894360D1-F208-4125-8FF9-5145CC392998}"/>
               </a:ext>
             </a:extLst>
           </p:cNvPr>
@@ -6877,7 +6877,7 @@
           <p:cNvPr id="5" name="">
             <a:extLst xmlns:a="http://schemas.openxmlformats.org/drawingml/2006/main">
               <a:ext uri="{FF2B5EF4-FFF2-40B4-BE49-F238E27FC236}">
-                <a16:creationId xmlns:a16="http://schemas.microsoft.com/office/drawing/2014/main" id="{A779501D-6340-498D-B597-DC0133F202F3}"/>
+                <a16:creationId xmlns:a16="http://schemas.microsoft.com/office/drawing/2014/main" id="{EA642313-D182-4A58-989F-7093629C23EB}"/>
               </a:ext>
             </a:extLst>
           </p:cNvPr>
@@ -6934,7 +6934,7 @@
           <p:cNvPr id="6" name="">
             <a:extLst xmlns:a="http://schemas.openxmlformats.org/drawingml/2006/main">
               <a:ext uri="{FF2B5EF4-FFF2-40B4-BE49-F238E27FC236}">
-                <a16:creationId xmlns:a16="http://schemas.microsoft.com/office/drawing/2014/main" id="{2B6A94DC-AFF9-45BD-9B73-F12144D581A1}"/>
+                <a16:creationId xmlns:a16="http://schemas.microsoft.com/office/drawing/2014/main" id="{B6DAEF24-F293-495C-B5E1-90657D467A64}"/>
               </a:ext>
             </a:extLst>
           </p:cNvPr>
@@ -6989,7 +6989,7 @@
     </p:spTree>
     <p:extLst>
       <p:ext uri="{BB962C8B-B14F-4D97-AF65-F5344CB8AC3E}">
-        <p14:creationId xmlns:p14="http://schemas.microsoft.com/office/powerpoint/2010/main" val="891304097"/>
+        <p14:creationId xmlns:p14="http://schemas.microsoft.com/office/powerpoint/2010/main" val="982151372"/>
       </p:ext>
     </p:extLst>
   </p:cSld>

</xml_diff>